<commit_message>
Add rehearsal harness, backup demo video, and live-demo deck slide
Presentation-preparedness round: scripts/rehearse_demo.py measures the
narrated timeline (benign 0.12 -> alert at ~33s -> lateral movement at
~63s, verified through the dashboard UI path); make_backup_demo.py
renders the same beats into deliverables/backup_demo/ (frames + animated
GIF) as a fallback if live infra fails; build_deck.py gains slide 7
embedding those frames with measured timings. Also: Dockerfile for
containerized demo, trust-ledger registration for run_forecast, and
gitignore for live runtime data. 111 tests pass.
</commit_message>
<xml_diff>
--- a/deliverables/Trajectory_SIH26153_Idea_Deck.pptx
+++ b/deliverables/Trajectory_SIH26153_Idea_Deck.pptx
@@ -11,6 +11,7 @@
     <p:sldId id="259" r:id="rId10"/>
     <p:sldId id="260" r:id="rId11"/>
     <p:sldId id="261" r:id="rId12"/>
+    <p:sldId id="262" r:id="rId13"/>
   </p:sldIdLst>
   <p:sldSz cx="12191695" cy="6858000" type="screen4x3"/>
   <p:notesSz cx="6858000" cy="9144000"/>
@@ -15338,6 +15339,724 @@
 </p:sld>
 </file>
 
+<file path=ppt/slides/slide7.xml><?xml version="1.0" encoding="utf-8"?>
+<p:sld xmlns:a="http://schemas.openxmlformats.org/drawingml/2006/main" xmlns:p="http://schemas.openxmlformats.org/presentationml/2006/main" xmlns:r="http://schemas.openxmlformats.org/officeDocument/2006/relationships">
+  <p:cSld>
+    <p:bg>
+      <p:bgPr>
+        <a:solidFill>
+          <a:srgbClr val="0B1220"/>
+        </a:solidFill>
+        <a:effectLst/>
+      </p:bgPr>
+    </p:bg>
+    <p:spTree>
+      <p:nvGrpSpPr>
+        <p:cNvPr id="1" name=""/>
+        <p:cNvGrpSpPr/>
+        <p:nvPr/>
+      </p:nvGrpSpPr>
+      <p:grpSpPr/>
+      <p:sp>
+        <p:nvSpPr>
+          <p:cNvPr id="2" name="Rectangle 1"/>
+          <p:cNvSpPr/>
+          <p:nvPr/>
+        </p:nvSpPr>
+        <p:spPr>
+          <a:xfrm>
+            <a:off x="0" y="0"/>
+            <a:ext cx="12191695" cy="73152"/>
+          </a:xfrm>
+          <a:prstGeom prst="rect">
+            <a:avLst/>
+          </a:prstGeom>
+          <a:solidFill>
+            <a:srgbClr val="2ED3B7"/>
+          </a:solidFill>
+          <a:ln>
+            <a:noFill/>
+          </a:ln>
+          <a:effectLst/>
+        </p:spPr>
+        <p:style>
+          <a:lnRef idx="1">
+            <a:schemeClr val="accent1"/>
+          </a:lnRef>
+          <a:fillRef idx="3">
+            <a:schemeClr val="accent1"/>
+          </a:fillRef>
+          <a:effectRef idx="2">
+            <a:schemeClr val="accent1"/>
+          </a:effectRef>
+          <a:fontRef idx="minor">
+            <a:schemeClr val="lt1"/>
+          </a:fontRef>
+        </p:style>
+        <p:txBody>
+          <a:bodyPr rtlCol="0" anchor="ctr"/>
+          <a:lstStyle/>
+          <a:p>
+            <a:pPr algn="ctr"/>
+          </a:p>
+        </p:txBody>
+      </p:sp>
+      <p:sp>
+        <p:nvSpPr>
+          <p:cNvPr id="3" name="TextBox 2"/>
+          <p:cNvSpPr txBox="1"/>
+          <p:nvPr/>
+        </p:nvSpPr>
+        <p:spPr>
+          <a:xfrm>
+            <a:off x="411480" y="164592"/>
+            <a:ext cx="9601200" cy="548640"/>
+          </a:xfrm>
+          <a:prstGeom prst="rect">
+            <a:avLst/>
+          </a:prstGeom>
+          <a:noFill/>
+        </p:spPr>
+        <p:txBody>
+          <a:bodyPr wrap="square" anchor="t" lIns="73152" rIns="73152" tIns="36576" bIns="36576">
+            <a:spAutoFit/>
+          </a:bodyPr>
+          <a:lstStyle/>
+          <a:p>
+            <a:pPr algn="l">
+              <a:lnSpc>
+                <a:spcPct val="105000"/>
+              </a:lnSpc>
+              <a:spcAft>
+                <a:spcPts val="200"/>
+              </a:spcAft>
+            </a:pPr>
+            <a:r>
+              <a:rPr sz="2600" b="1">
+                <a:solidFill>
+                  <a:srgbClr val="EEF2F8"/>
+                </a:solidFill>
+                <a:latin typeface="Calibri"/>
+              </a:rPr>
+              <a:t>Live Demo — Watch the AI Detect an Attack</a:t>
+            </a:r>
+          </a:p>
+        </p:txBody>
+      </p:sp>
+      <p:sp>
+        <p:nvSpPr>
+          <p:cNvPr id="4" name="TextBox 3"/>
+          <p:cNvSpPr txBox="1"/>
+          <p:nvPr/>
+        </p:nvSpPr>
+        <p:spPr>
+          <a:xfrm>
+            <a:off x="411480" y="658368"/>
+            <a:ext cx="10058400" cy="365760"/>
+          </a:xfrm>
+          <a:prstGeom prst="rect">
+            <a:avLst/>
+          </a:prstGeom>
+          <a:noFill/>
+        </p:spPr>
+        <p:txBody>
+          <a:bodyPr wrap="square" anchor="t" lIns="73152" rIns="73152" tIns="36576" bIns="36576">
+            <a:spAutoFit/>
+          </a:bodyPr>
+          <a:lstStyle/>
+          <a:p>
+            <a:pPr algn="l">
+              <a:lnSpc>
+                <a:spcPct val="105000"/>
+              </a:lnSpc>
+              <a:spcAft>
+                <a:spcPts val="200"/>
+              </a:spcAft>
+            </a:pPr>
+            <a:r>
+              <a:rPr sz="1300" b="0">
+                <a:solidFill>
+                  <a:srgbClr val="9FACC2"/>
+                </a:solidFill>
+                <a:latin typeface="Calibri"/>
+              </a:rPr>
+              <a:t>Real-time detection on a localhost attack simulation; deterministic and rehearsed</a:t>
+            </a:r>
+          </a:p>
+        </p:txBody>
+      </p:sp>
+      <p:sp>
+        <p:nvSpPr>
+          <p:cNvPr id="5" name="TextBox 4"/>
+          <p:cNvSpPr txBox="1"/>
+          <p:nvPr/>
+        </p:nvSpPr>
+        <p:spPr>
+          <a:xfrm>
+            <a:off x="9265615" y="182880"/>
+            <a:ext cx="2560320" cy="365760"/>
+          </a:xfrm>
+          <a:prstGeom prst="rect">
+            <a:avLst/>
+          </a:prstGeom>
+          <a:noFill/>
+        </p:spPr>
+        <p:txBody>
+          <a:bodyPr wrap="square" anchor="t" lIns="73152" rIns="73152" tIns="36576" bIns="36576">
+            <a:spAutoFit/>
+          </a:bodyPr>
+          <a:lstStyle/>
+          <a:p>
+            <a:pPr algn="r">
+              <a:lnSpc>
+                <a:spcPct val="105000"/>
+              </a:lnSpc>
+              <a:spcAft>
+                <a:spcPts val="200"/>
+              </a:spcAft>
+            </a:pPr>
+            <a:r>
+              <a:rPr sz="1000" b="0">
+                <a:solidFill>
+                  <a:srgbClr val="9FACC2"/>
+                </a:solidFill>
+                <a:latin typeface="Calibri"/>
+              </a:rPr>
+              <a:t>TRAJECTORY  |  SIH26153  |  7/6</a:t>
+            </a:r>
+          </a:p>
+        </p:txBody>
+      </p:sp>
+      <p:sp>
+        <p:nvSpPr>
+          <p:cNvPr id="6" name="Rounded Rectangle 5"/>
+          <p:cNvSpPr/>
+          <p:nvPr/>
+        </p:nvSpPr>
+        <p:spPr>
+          <a:xfrm>
+            <a:off x="411480" y="1097280"/>
+            <a:ext cx="5394960" cy="4206240"/>
+          </a:xfrm>
+          <a:prstGeom prst="roundRect">
+            <a:avLst>
+              <a:gd name="adj" fmla="val 6000"/>
+            </a:avLst>
+          </a:prstGeom>
+          <a:solidFill>
+            <a:srgbClr val="141E33"/>
+          </a:solidFill>
+          <a:ln>
+            <a:noFill/>
+          </a:ln>
+          <a:effectLst/>
+        </p:spPr>
+        <p:style>
+          <a:lnRef idx="1">
+            <a:schemeClr val="accent1"/>
+          </a:lnRef>
+          <a:fillRef idx="3">
+            <a:schemeClr val="accent1"/>
+          </a:fillRef>
+          <a:effectRef idx="2">
+            <a:schemeClr val="accent1"/>
+          </a:effectRef>
+          <a:fontRef idx="minor">
+            <a:schemeClr val="lt1"/>
+          </a:fontRef>
+        </p:style>
+        <p:txBody>
+          <a:bodyPr rtlCol="0" anchor="ctr"/>
+          <a:lstStyle/>
+          <a:p>
+            <a:pPr algn="ctr"/>
+          </a:p>
+        </p:txBody>
+      </p:sp>
+      <p:sp>
+        <p:nvSpPr>
+          <p:cNvPr id="7" name="TextBox 6"/>
+          <p:cNvSpPr txBox="1"/>
+          <p:nvPr/>
+        </p:nvSpPr>
+        <p:spPr>
+          <a:xfrm>
+            <a:off x="502920" y="1170432"/>
+            <a:ext cx="5212080" cy="365760"/>
+          </a:xfrm>
+          <a:prstGeom prst="rect">
+            <a:avLst/>
+          </a:prstGeom>
+          <a:noFill/>
+        </p:spPr>
+        <p:txBody>
+          <a:bodyPr wrap="square" anchor="t" lIns="73152" rIns="73152" tIns="36576" bIns="36576">
+            <a:spAutoFit/>
+          </a:bodyPr>
+          <a:lstStyle/>
+          <a:p>
+            <a:pPr algn="l">
+              <a:lnSpc>
+                <a:spcPct val="105000"/>
+              </a:lnSpc>
+              <a:spcAft>
+                <a:spcPts val="200"/>
+              </a:spcAft>
+            </a:pPr>
+            <a:r>
+              <a:rPr sz="1300" b="1">
+                <a:solidFill>
+                  <a:srgbClr val="2ED3B7"/>
+                </a:solidFill>
+                <a:latin typeface="Calibri"/>
+              </a:rPr>
+              <a:t>Stage Storyline (measured in rehearsal)</a:t>
+            </a:r>
+          </a:p>
+        </p:txBody>
+      </p:sp>
+      <p:sp>
+        <p:nvSpPr>
+          <p:cNvPr id="8" name="TextBox 7"/>
+          <p:cNvSpPr txBox="1"/>
+          <p:nvPr/>
+        </p:nvSpPr>
+        <p:spPr>
+          <a:xfrm>
+            <a:off x="502920" y="1536192"/>
+            <a:ext cx="5212080" cy="3703320"/>
+          </a:xfrm>
+          <a:prstGeom prst="rect">
+            <a:avLst/>
+          </a:prstGeom>
+          <a:noFill/>
+        </p:spPr>
+        <p:txBody>
+          <a:bodyPr wrap="square" anchor="t" lIns="73152" rIns="73152" tIns="36576" bIns="36576">
+            <a:spAutoFit/>
+          </a:bodyPr>
+          <a:lstStyle/>
+          <a:p>
+            <a:pPr algn="l">
+              <a:lnSpc>
+                <a:spcPct val="105000"/>
+              </a:lnSpc>
+              <a:spcAft>
+                <a:spcPts val="200"/>
+              </a:spcAft>
+            </a:pPr>
+            <a:r>
+              <a:rPr sz="1100" b="0">
+                <a:solidFill>
+                  <a:srgbClr val="EEF2F8"/>
+                </a:solidFill>
+                <a:latin typeface="Calibri"/>
+              </a:rPr>
+              <a:t>• 0:00 — Train the models live (~4 seconds, deterministic seed)</a:t>
+            </a:r>
+          </a:p>
+          <a:p>
+            <a:pPr algn="l">
+              <a:lnSpc>
+                <a:spcPct val="105000"/>
+              </a:lnSpc>
+              <a:spcAft>
+                <a:spcPts val="200"/>
+              </a:spcAft>
+            </a:pPr>
+            <a:r>
+              <a:rPr sz="1100" b="0">
+                <a:solidFill>
+                  <a:srgbClr val="EEF2F8"/>
+                </a:solidFill>
+                <a:latin typeface="Calibri"/>
+              </a:rPr>
+              <a:t>• 0:10 — Press Start: benign chatter begins</a:t>
+            </a:r>
+          </a:p>
+          <a:p>
+            <a:pPr algn="l">
+              <a:lnSpc>
+                <a:spcPct val="105000"/>
+              </a:lnSpc>
+              <a:spcAft>
+                <a:spcPts val="200"/>
+              </a:spcAft>
+            </a:pPr>
+            <a:r>
+              <a:rPr sz="1100" b="0">
+                <a:solidFill>
+                  <a:srgbClr val="EEF2F8"/>
+                </a:solidFill>
+                <a:latin typeface="Calibri"/>
+              </a:rPr>
+              <a:t>• 0:30 — Quiet window: P(infiltration) = 0.12, no false alarms</a:t>
+            </a:r>
+          </a:p>
+          <a:p>
+            <a:pPr algn="l">
+              <a:lnSpc>
+                <a:spcPct val="105000"/>
+              </a:lnSpc>
+              <a:spcAft>
+                <a:spcPts val="200"/>
+              </a:spcAft>
+            </a:pPr>
+            <a:r>
+              <a:rPr sz="1100" b="0">
+                <a:solidFill>
+                  <a:srgbClr val="EEF2F8"/>
+                </a:solidFill>
+                <a:latin typeface="Calibri"/>
+              </a:rPr>
+              <a:t>• 0:33 — ALERT: scan burst detected at P = 0.97</a:t>
+            </a:r>
+          </a:p>
+          <a:p>
+            <a:pPr algn="l">
+              <a:lnSpc>
+                <a:spcPct val="105000"/>
+              </a:lnSpc>
+              <a:spcAft>
+                <a:spcPts val="200"/>
+              </a:spcAft>
+            </a:pPr>
+            <a:r>
+              <a:rPr sz="1100" b="0">
+                <a:solidFill>
+                  <a:srgbClr val="EEF2F8"/>
+                </a:solidFill>
+                <a:latin typeface="Calibri"/>
+              </a:rPr>
+              <a:t>•          Stage: Initial Access — MITRE ATT&amp;CK TA0001</a:t>
+            </a:r>
+          </a:p>
+          <a:p>
+            <a:pPr algn="l">
+              <a:lnSpc>
+                <a:spcPct val="105000"/>
+              </a:lnSpc>
+              <a:spcAft>
+                <a:spcPts val="200"/>
+              </a:spcAft>
+            </a:pPr>
+            <a:r>
+              <a:rPr sz="1100" b="0">
+                <a:solidFill>
+                  <a:srgbClr val="EEF2F8"/>
+                </a:solidFill>
+                <a:latin typeface="Calibri"/>
+              </a:rPr>
+              <a:t>• 0:48 — Failed logins: P = 1.00, evidence panel grows</a:t>
+            </a:r>
+          </a:p>
+          <a:p>
+            <a:pPr algn="l">
+              <a:lnSpc>
+                <a:spcPct val="105000"/>
+              </a:lnSpc>
+              <a:spcAft>
+                <a:spcPts val="200"/>
+              </a:spcAft>
+            </a:pPr>
+            <a:r>
+              <a:rPr sz="1100" b="0">
+                <a:solidFill>
+                  <a:srgbClr val="EEF2F8"/>
+                </a:solidFill>
+                <a:latin typeface="Calibri"/>
+              </a:rPr>
+              <a:t>• 1:03 — ESCALATION: Lateral Movement — MITRE TA0008</a:t>
+            </a:r>
+          </a:p>
+          <a:p>
+            <a:pPr algn="l">
+              <a:lnSpc>
+                <a:spcPct val="105000"/>
+              </a:lnSpc>
+              <a:spcAft>
+                <a:spcPts val="200"/>
+              </a:spcAft>
+            </a:pPr>
+            <a:r>
+              <a:rPr sz="1100" b="0">
+                <a:solidFill>
+                  <a:srgbClr val="EEF2F8"/>
+                </a:solidFill>
+                <a:latin typeface="Calibri"/>
+              </a:rPr>
+              <a:t>• Same trained artifacts as the offline benchmark</a:t>
+            </a:r>
+          </a:p>
+          <a:p>
+            <a:pPr algn="l">
+              <a:lnSpc>
+                <a:spcPct val="105000"/>
+              </a:lnSpc>
+              <a:spcAft>
+                <a:spcPts val="200"/>
+              </a:spcAft>
+            </a:pPr>
+            <a:r>
+              <a:rPr sz="1100" b="0">
+                <a:solidFill>
+                  <a:srgbClr val="EEF2F8"/>
+                </a:solidFill>
+                <a:latin typeface="Calibri"/>
+              </a:rPr>
+              <a:t>• Sources: demo attack, CIC-IDS2017 replay, live capture</a:t>
+            </a:r>
+          </a:p>
+        </p:txBody>
+      </p:sp>
+      <p:pic>
+        <p:nvPicPr>
+          <p:cNvPr id="9" name="Picture 8" descr="frame_0_t0s.png"/>
+          <p:cNvPicPr>
+            <a:picLocks noChangeAspect="1"/>
+          </p:cNvPicPr>
+          <p:nvPr/>
+        </p:nvPicPr>
+        <p:blipFill>
+          <a:blip r:embed="rId2"/>
+          <a:stretch>
+            <a:fillRect/>
+          </a:stretch>
+        </p:blipFill>
+        <p:spPr>
+          <a:xfrm>
+            <a:off x="5989320" y="1143000"/>
+            <a:ext cx="2377440" cy="1337310"/>
+          </a:xfrm>
+          <a:prstGeom prst="rect">
+            <a:avLst/>
+          </a:prstGeom>
+        </p:spPr>
+      </p:pic>
+      <p:sp>
+        <p:nvSpPr>
+          <p:cNvPr id="10" name="TextBox 9"/>
+          <p:cNvSpPr txBox="1"/>
+          <p:nvPr/>
+        </p:nvSpPr>
+        <p:spPr>
+          <a:xfrm>
+            <a:off x="8458200" y="1645920"/>
+            <a:ext cx="3291840" cy="365760"/>
+          </a:xfrm>
+          <a:prstGeom prst="rect">
+            <a:avLst/>
+          </a:prstGeom>
+          <a:noFill/>
+        </p:spPr>
+        <p:txBody>
+          <a:bodyPr wrap="square" anchor="t" lIns="73152" rIns="73152" tIns="36576" bIns="36576">
+            <a:spAutoFit/>
+          </a:bodyPr>
+          <a:lstStyle/>
+          <a:p>
+            <a:pPr algn="l">
+              <a:lnSpc>
+                <a:spcPct val="105000"/>
+              </a:lnSpc>
+              <a:spcAft>
+                <a:spcPts val="200"/>
+              </a:spcAft>
+            </a:pPr>
+            <a:r>
+              <a:rPr sz="1000" b="0">
+                <a:solidFill>
+                  <a:srgbClr val="2ED3B7"/>
+                </a:solidFill>
+                <a:latin typeface="Calibri"/>
+              </a:rPr>
+              <a:t>t=0 — benign, P=0.12</a:t>
+            </a:r>
+          </a:p>
+        </p:txBody>
+      </p:sp>
+      <p:pic>
+        <p:nvPicPr>
+          <p:cNvPr id="11" name="Picture 10" descr="frame_1_t33s.png"/>
+          <p:cNvPicPr>
+            <a:picLocks noChangeAspect="1"/>
+          </p:cNvPicPr>
+          <p:nvPr/>
+        </p:nvPicPr>
+        <p:blipFill>
+          <a:blip r:embed="rId3"/>
+          <a:stretch>
+            <a:fillRect/>
+          </a:stretch>
+        </p:blipFill>
+        <p:spPr>
+          <a:xfrm>
+            <a:off x="5989320" y="2560320"/>
+            <a:ext cx="2377440" cy="1337310"/>
+          </a:xfrm>
+          <a:prstGeom prst="rect">
+            <a:avLst/>
+          </a:prstGeom>
+        </p:spPr>
+      </p:pic>
+      <p:sp>
+        <p:nvSpPr>
+          <p:cNvPr id="12" name="TextBox 11"/>
+          <p:cNvSpPr txBox="1"/>
+          <p:nvPr/>
+        </p:nvSpPr>
+        <p:spPr>
+          <a:xfrm>
+            <a:off x="8458200" y="3063240"/>
+            <a:ext cx="3291840" cy="365760"/>
+          </a:xfrm>
+          <a:prstGeom prst="rect">
+            <a:avLst/>
+          </a:prstGeom>
+          <a:noFill/>
+        </p:spPr>
+        <p:txBody>
+          <a:bodyPr wrap="square" anchor="t" lIns="73152" rIns="73152" tIns="36576" bIns="36576">
+            <a:spAutoFit/>
+          </a:bodyPr>
+          <a:lstStyle/>
+          <a:p>
+            <a:pPr algn="l">
+              <a:lnSpc>
+                <a:spcPct val="105000"/>
+              </a:lnSpc>
+              <a:spcAft>
+                <a:spcPts val="200"/>
+              </a:spcAft>
+            </a:pPr>
+            <a:r>
+              <a:rPr sz="1000" b="0">
+                <a:solidFill>
+                  <a:srgbClr val="2ED3B7"/>
+                </a:solidFill>
+                <a:latin typeface="Calibri"/>
+              </a:rPr>
+              <a:t>t=33s — ALERT, P=0.97</a:t>
+            </a:r>
+          </a:p>
+        </p:txBody>
+      </p:sp>
+      <p:pic>
+        <p:nvPicPr>
+          <p:cNvPr id="13" name="Picture 12" descr="frame_3_t63s.png"/>
+          <p:cNvPicPr>
+            <a:picLocks noChangeAspect="1"/>
+          </p:cNvPicPr>
+          <p:nvPr/>
+        </p:nvPicPr>
+        <p:blipFill>
+          <a:blip r:embed="rId4"/>
+          <a:stretch>
+            <a:fillRect/>
+          </a:stretch>
+        </p:blipFill>
+        <p:spPr>
+          <a:xfrm>
+            <a:off x="5989320" y="3977639"/>
+            <a:ext cx="2377440" cy="1337310"/>
+          </a:xfrm>
+          <a:prstGeom prst="rect">
+            <a:avLst/>
+          </a:prstGeom>
+        </p:spPr>
+      </p:pic>
+      <p:sp>
+        <p:nvSpPr>
+          <p:cNvPr id="14" name="TextBox 13"/>
+          <p:cNvSpPr txBox="1"/>
+          <p:nvPr/>
+        </p:nvSpPr>
+        <p:spPr>
+          <a:xfrm>
+            <a:off x="8458200" y="4480559"/>
+            <a:ext cx="3291840" cy="365760"/>
+          </a:xfrm>
+          <a:prstGeom prst="rect">
+            <a:avLst/>
+          </a:prstGeom>
+          <a:noFill/>
+        </p:spPr>
+        <p:txBody>
+          <a:bodyPr wrap="square" anchor="t" lIns="73152" rIns="73152" tIns="36576" bIns="36576">
+            <a:spAutoFit/>
+          </a:bodyPr>
+          <a:lstStyle/>
+          <a:p>
+            <a:pPr algn="l">
+              <a:lnSpc>
+                <a:spcPct val="105000"/>
+              </a:lnSpc>
+              <a:spcAft>
+                <a:spcPts val="200"/>
+              </a:spcAft>
+            </a:pPr>
+            <a:r>
+              <a:rPr sz="1000" b="0">
+                <a:solidFill>
+                  <a:srgbClr val="2ED3B7"/>
+                </a:solidFill>
+                <a:latin typeface="Calibri"/>
+              </a:rPr>
+              <a:t>t=63s — Lateral Movement</a:t>
+            </a:r>
+          </a:p>
+        </p:txBody>
+      </p:sp>
+      <p:sp>
+        <p:nvSpPr>
+          <p:cNvPr id="15" name="TextBox 14"/>
+          <p:cNvSpPr txBox="1"/>
+          <p:nvPr/>
+        </p:nvSpPr>
+        <p:spPr>
+          <a:xfrm>
+            <a:off x="411480" y="6492240"/>
+            <a:ext cx="11368735" cy="274320"/>
+          </a:xfrm>
+          <a:prstGeom prst="rect">
+            <a:avLst/>
+          </a:prstGeom>
+          <a:noFill/>
+        </p:spPr>
+        <p:txBody>
+          <a:bodyPr wrap="square" anchor="t" lIns="73152" rIns="73152" tIns="36576" bIns="36576">
+            <a:spAutoFit/>
+          </a:bodyPr>
+          <a:lstStyle/>
+          <a:p>
+            <a:pPr algn="l">
+              <a:lnSpc>
+                <a:spcPct val="105000"/>
+              </a:lnSpc>
+              <a:spcAft>
+                <a:spcPts val="200"/>
+              </a:spcAft>
+            </a:pPr>
+            <a:r>
+              <a:rPr sz="900" b="0">
+                <a:solidFill>
+                  <a:srgbClr val="9FACC2"/>
+                </a:solidFill>
+                <a:latin typeface="Calibri"/>
+              </a:rPr>
+              <a:t>Backup if live infra fails: deliverables/backup_demo/backup_demo.gif (animated) — same numbers as the live run.</a:t>
+            </a:r>
+          </a:p>
+        </p:txBody>
+      </p:sp>
+    </p:spTree>
+  </p:cSld>
+  <p:clrMapOvr>
+    <a:masterClrMapping/>
+  </p:clrMapOvr>
+</p:sld>
+</file>
+
 <file path=ppt/theme/theme1.xml><?xml version="1.0" encoding="utf-8"?>
 <a:theme xmlns:a="http://schemas.openxmlformats.org/drawingml/2006/main" name="Office Theme">
   <a:themeElements>

</xml_diff>

<commit_message>
Update deck slide 7 and backup demo with measured rehearsal timings
Numbers now come from the fresh rehearsal run (reports/generated/rehearsal.json):
alert at 0:34 at P=0.99, escalation at 1:04, benign window at 0:19. Regenerated
the backup frames and GIF so the backup can never contradict the live demo.
</commit_message>
<xml_diff>
--- a/deliverables/Trajectory_SIH26153_Idea_Deck.pptx
+++ b/deliverables/Trajectory_SIH26153_Idea_Deck.pptx
@@ -15652,7 +15652,7 @@
                 </a:solidFill>
                 <a:latin typeface="Calibri"/>
               </a:rPr>
-              <a:t>• 0:00 — Train the models live (~4 seconds, deterministic seed)</a:t>
+              <a:t>• 0:00 — Train the models live (~3 seconds, deterministic seed)</a:t>
             </a:r>
           </a:p>
           <a:p>
@@ -15690,7 +15690,7 @@
                 </a:solidFill>
                 <a:latin typeface="Calibri"/>
               </a:rPr>
-              <a:t>• 0:30 — Quiet window: P(infiltration) = 0.12, no false alarms</a:t>
+              <a:t>• 0:19 — Quiet window: P(infiltration) = 0.12, no false alarms</a:t>
             </a:r>
           </a:p>
           <a:p>
@@ -15709,7 +15709,7 @@
                 </a:solidFill>
                 <a:latin typeface="Calibri"/>
               </a:rPr>
-              <a:t>• 0:33 — ALERT: scan burst detected at P = 0.97</a:t>
+              <a:t>• 0:34 — ALERT: scan burst detected at P = 0.99</a:t>
             </a:r>
           </a:p>
           <a:p>
@@ -15747,7 +15747,7 @@
                 </a:solidFill>
                 <a:latin typeface="Calibri"/>
               </a:rPr>
-              <a:t>• 0:48 — Failed logins: P = 1.00, evidence panel grows</a:t>
+              <a:t>• 0:49 — Failed logins: P = 1.00, evidence panel grows</a:t>
             </a:r>
           </a:p>
           <a:p>
@@ -15766,7 +15766,7 @@
                 </a:solidFill>
                 <a:latin typeface="Calibri"/>
               </a:rPr>
-              <a:t>• 1:03 — ESCALATION: Lateral Movement — MITRE TA0008</a:t>
+              <a:t>• 1:04 — ESCALATION: Lateral Movement — MITRE TA0008</a:t>
             </a:r>
           </a:p>
           <a:p>
@@ -15811,7 +15811,7 @@
       </p:sp>
       <p:pic>
         <p:nvPicPr>
-          <p:cNvPr id="9" name="Picture 8" descr="frame_0_t0s.png"/>
+          <p:cNvPr id="9" name="Picture 8" descr="frame_0_t19s.png"/>
           <p:cNvPicPr>
             <a:picLocks noChangeAspect="1"/>
           </p:cNvPicPr>
@@ -15870,14 +15870,14 @@
                 </a:solidFill>
                 <a:latin typeface="Calibri"/>
               </a:rPr>
-              <a:t>t=0 — benign, P=0.12</a:t>
+              <a:t>t=19s — benign, P=0.12</a:t>
             </a:r>
           </a:p>
         </p:txBody>
       </p:sp>
       <p:pic>
         <p:nvPicPr>
-          <p:cNvPr id="11" name="Picture 10" descr="frame_1_t33s.png"/>
+          <p:cNvPr id="11" name="Picture 10" descr="frame_1_t34s.png"/>
           <p:cNvPicPr>
             <a:picLocks noChangeAspect="1"/>
           </p:cNvPicPr>
@@ -15936,14 +15936,14 @@
                 </a:solidFill>
                 <a:latin typeface="Calibri"/>
               </a:rPr>
-              <a:t>t=33s — ALERT, P=0.97</a:t>
+              <a:t>t=34s — ALERT, P=0.99</a:t>
             </a:r>
           </a:p>
         </p:txBody>
       </p:sp>
       <p:pic>
         <p:nvPicPr>
-          <p:cNvPr id="13" name="Picture 12" descr="frame_3_t63s.png"/>
+          <p:cNvPr id="13" name="Picture 12" descr="frame_3_t64s.png"/>
           <p:cNvPicPr>
             <a:picLocks noChangeAspect="1"/>
           </p:cNvPicPr>
@@ -16002,7 +16002,7 @@
                 </a:solidFill>
                 <a:latin typeface="Calibri"/>
               </a:rPr>
-              <a:t>t=63s — Lateral Movement</a:t>
+              <a:t>t=64s — Lateral Movement</a:t>
             </a:r>
           </a:p>
         </p:txBody>

</xml_diff>

<commit_message>
Add auth flow and role matrix to the deck architecture slide
</commit_message>
<xml_diff>
--- a/deliverables/Trajectory_SIH26153_Idea_Deck.pptx
+++ b/deliverables/Trajectory_SIH26153_Idea_Deck.pptx
@@ -6524,7 +6524,7 @@
         <p:spPr>
           <a:xfrm>
             <a:off x="411480" y="1097280"/>
-            <a:ext cx="5669280" cy="658368"/>
+            <a:ext cx="5669280" cy="548640"/>
           </a:xfrm>
           <a:prstGeom prst="roundRect">
             <a:avLst>
@@ -6572,7 +6572,7 @@
         <p:spPr>
           <a:xfrm>
             <a:off x="502920" y="1143000"/>
-            <a:ext cx="1005840" cy="548640"/>
+            <a:ext cx="1005840" cy="457200"/>
           </a:xfrm>
           <a:prstGeom prst="rect">
             <a:avLst/>
@@ -6613,8 +6613,8 @@
         </p:nvSpPr>
         <p:spPr>
           <a:xfrm>
-            <a:off x="1508760" y="1143000"/>
-            <a:ext cx="4480560" cy="566928"/>
+            <a:off x="1508760" y="1115568"/>
+            <a:ext cx="4480560" cy="512064"/>
           </a:xfrm>
           <a:prstGeom prst="rect">
             <a:avLst/>
@@ -6636,13 +6636,13 @@
               </a:spcAft>
             </a:pPr>
             <a:r>
-              <a:rPr sz="1000" b="0">
+              <a:rPr sz="950" b="0">
                 <a:solidFill>
                   <a:srgbClr val="EEF2F8"/>
                 </a:solidFill>
                 <a:latin typeface="Calibri"/>
               </a:rPr>
-              <a:t>Flow CSV  |  PCAP captures  -&gt;  normalization + packet feature extraction</a:t>
+              <a:t>Flow CSV  |  PCAP captures  |  JSONL/syslog tail  |  Scapy live capture</a:t>
             </a:r>
           </a:p>
         </p:txBody>
@@ -6655,8 +6655,8 @@
         </p:nvSpPr>
         <p:spPr>
           <a:xfrm>
-            <a:off x="411480" y="1828800"/>
-            <a:ext cx="5669280" cy="658368"/>
+            <a:off x="411480" y="1700784"/>
+            <a:ext cx="5669280" cy="548640"/>
           </a:xfrm>
           <a:prstGeom prst="roundRect">
             <a:avLst>
@@ -6703,8 +6703,8 @@
         </p:nvSpPr>
         <p:spPr>
           <a:xfrm>
-            <a:off x="502920" y="1874520"/>
-            <a:ext cx="1005840" cy="548640"/>
+            <a:off x="502920" y="1746504"/>
+            <a:ext cx="1005840" cy="457200"/>
           </a:xfrm>
           <a:prstGeom prst="rect">
             <a:avLst/>
@@ -6745,8 +6745,8 @@
         </p:nvSpPr>
         <p:spPr>
           <a:xfrm>
-            <a:off x="1508760" y="1874520"/>
-            <a:ext cx="4480560" cy="566928"/>
+            <a:off x="1508760" y="1719072"/>
+            <a:ext cx="4480560" cy="512064"/>
           </a:xfrm>
           <a:prstGeom prst="rect">
             <a:avLst/>
@@ -6768,7 +6768,7 @@
               </a:spcAft>
             </a:pPr>
             <a:r>
-              <a:rPr sz="1000" b="0">
+              <a:rPr sz="950" b="0">
                 <a:solidFill>
                   <a:srgbClr val="EEF2F8"/>
                 </a:solidFill>
@@ -6787,8 +6787,8 @@
         </p:nvSpPr>
         <p:spPr>
           <a:xfrm>
-            <a:off x="411480" y="2560320"/>
-            <a:ext cx="5669280" cy="658368"/>
+            <a:off x="411480" y="2304288"/>
+            <a:ext cx="5669280" cy="548640"/>
           </a:xfrm>
           <a:prstGeom prst="roundRect">
             <a:avLst>
@@ -6835,8 +6835,8 @@
         </p:nvSpPr>
         <p:spPr>
           <a:xfrm>
-            <a:off x="502920" y="2606040"/>
-            <a:ext cx="1005840" cy="548640"/>
+            <a:off x="502920" y="2350008"/>
+            <a:ext cx="1005840" cy="457200"/>
           </a:xfrm>
           <a:prstGeom prst="rect">
             <a:avLst/>
@@ -6877,8 +6877,8 @@
         </p:nvSpPr>
         <p:spPr>
           <a:xfrm>
-            <a:off x="1508760" y="2606040"/>
-            <a:ext cx="4480560" cy="566928"/>
+            <a:off x="1508760" y="2322576"/>
+            <a:ext cx="4480560" cy="512064"/>
           </a:xfrm>
           <a:prstGeom prst="rect">
             <a:avLst/>
@@ -6900,7 +6900,7 @@
               </a:spcAft>
             </a:pPr>
             <a:r>
-              <a:rPr sz="1000" b="0">
+              <a:rPr sz="950" b="0">
                 <a:solidFill>
                   <a:srgbClr val="EEF2F8"/>
                 </a:solidFill>
@@ -6919,8 +6919,8 @@
         </p:nvSpPr>
         <p:spPr>
           <a:xfrm>
-            <a:off x="411480" y="3291840"/>
-            <a:ext cx="5669280" cy="658368"/>
+            <a:off x="411480" y="2907792"/>
+            <a:ext cx="5669280" cy="548640"/>
           </a:xfrm>
           <a:prstGeom prst="roundRect">
             <a:avLst>
@@ -6967,8 +6967,8 @@
         </p:nvSpPr>
         <p:spPr>
           <a:xfrm>
-            <a:off x="502920" y="3337560"/>
-            <a:ext cx="1005840" cy="548640"/>
+            <a:off x="502920" y="2953512"/>
+            <a:ext cx="1005840" cy="457200"/>
           </a:xfrm>
           <a:prstGeom prst="rect">
             <a:avLst/>
@@ -7009,8 +7009,8 @@
         </p:nvSpPr>
         <p:spPr>
           <a:xfrm>
-            <a:off x="1508760" y="3337560"/>
-            <a:ext cx="4480560" cy="566928"/>
+            <a:off x="1508760" y="2926080"/>
+            <a:ext cx="4480560" cy="512064"/>
           </a:xfrm>
           <a:prstGeom prst="rect">
             <a:avLst/>
@@ -7032,7 +7032,7 @@
               </a:spcAft>
             </a:pPr>
             <a:r>
-              <a:rPr sz="1000" b="0">
+              <a:rPr sz="950" b="0">
                 <a:solidFill>
                   <a:srgbClr val="EEF2F8"/>
                 </a:solidFill>
@@ -7051,8 +7051,8 @@
         </p:nvSpPr>
         <p:spPr>
           <a:xfrm>
-            <a:off x="411480" y="4023360"/>
-            <a:ext cx="5669280" cy="658368"/>
+            <a:off x="411480" y="3511296"/>
+            <a:ext cx="5669280" cy="548640"/>
           </a:xfrm>
           <a:prstGeom prst="roundRect">
             <a:avLst>
@@ -7099,8 +7099,8 @@
         </p:nvSpPr>
         <p:spPr>
           <a:xfrm>
-            <a:off x="502920" y="4069080"/>
-            <a:ext cx="1005840" cy="548640"/>
+            <a:off x="502920" y="3557016"/>
+            <a:ext cx="1005840" cy="457200"/>
           </a:xfrm>
           <a:prstGeom prst="rect">
             <a:avLst/>
@@ -7128,7 +7128,7 @@
                 </a:solidFill>
                 <a:latin typeface="Calibri"/>
               </a:rPr>
-              <a:t>UI</a:t>
+              <a:t>API</a:t>
             </a:r>
           </a:p>
         </p:txBody>
@@ -7141,8 +7141,8 @@
         </p:nvSpPr>
         <p:spPr>
           <a:xfrm>
-            <a:off x="1508760" y="4069080"/>
-            <a:ext cx="4480560" cy="566928"/>
+            <a:off x="1508760" y="3529584"/>
+            <a:ext cx="4480560" cy="512064"/>
           </a:xfrm>
           <a:prstGeom prst="rect">
             <a:avLst/>
@@ -7164,13 +7164,13 @@
               </a:spcAft>
             </a:pPr>
             <a:r>
-              <a:rPr sz="1000" b="0">
+              <a:rPr sz="950" b="0">
                 <a:solidFill>
                   <a:srgbClr val="EEF2F8"/>
                 </a:solidFill>
                 <a:latin typeface="Calibri"/>
               </a:rPr>
-              <a:t>Offline analyst dashboard (Streamlit/Flask + Plotly)</a:t>
+              <a:t>FastAPI REST: /v1/forecast, /v1/detect, /v1/alerts — same checksummed artifacts as the UI</a:t>
             </a:r>
           </a:p>
         </p:txBody>
@@ -7183,443 +7183,8 @@
         </p:nvSpPr>
         <p:spPr>
           <a:xfrm>
-            <a:off x="411480" y="4846320"/>
-            <a:ext cx="2743200" cy="1600200"/>
-          </a:xfrm>
-          <a:prstGeom prst="roundRect">
-            <a:avLst>
-              <a:gd name="adj" fmla="val 6000"/>
-            </a:avLst>
-          </a:prstGeom>
-          <a:solidFill>
-            <a:srgbClr val="141E33"/>
-          </a:solidFill>
-          <a:ln>
-            <a:noFill/>
-          </a:ln>
-          <a:effectLst/>
-        </p:spPr>
-        <p:style>
-          <a:lnRef idx="1">
-            <a:schemeClr val="accent1"/>
-          </a:lnRef>
-          <a:fillRef idx="3">
-            <a:schemeClr val="accent1"/>
-          </a:fillRef>
-          <a:effectRef idx="2">
-            <a:schemeClr val="accent1"/>
-          </a:effectRef>
-          <a:fontRef idx="minor">
-            <a:schemeClr val="lt1"/>
-          </a:fontRef>
-        </p:style>
-        <p:txBody>
-          <a:bodyPr rtlCol="0" anchor="ctr"/>
-          <a:lstStyle/>
-          <a:p>
-            <a:pPr algn="ctr"/>
-          </a:p>
-        </p:txBody>
-      </p:sp>
-      <p:sp>
-        <p:nvSpPr>
-          <p:cNvPr id="22" name="TextBox 21"/>
-          <p:cNvSpPr txBox="1"/>
-          <p:nvPr/>
-        </p:nvSpPr>
-        <p:spPr>
-          <a:xfrm>
-            <a:off x="502920" y="4919472"/>
-            <a:ext cx="2560320" cy="365760"/>
-          </a:xfrm>
-          <a:prstGeom prst="rect">
-            <a:avLst/>
-          </a:prstGeom>
-          <a:noFill/>
-        </p:spPr>
-        <p:txBody>
-          <a:bodyPr wrap="square" anchor="t" lIns="73152" rIns="73152" tIns="36576" bIns="36576">
-            <a:spAutoFit/>
-          </a:bodyPr>
-          <a:lstStyle/>
-          <a:p>
-            <a:pPr algn="l">
-              <a:lnSpc>
-                <a:spcPct val="105000"/>
-              </a:lnSpc>
-              <a:spcAft>
-                <a:spcPts val="200"/>
-              </a:spcAft>
-            </a:pPr>
-            <a:r>
-              <a:rPr sz="1300" b="1">
-                <a:solidFill>
-                  <a:srgbClr val="2ED3B7"/>
-                </a:solidFill>
-                <a:latin typeface="Calibri"/>
-              </a:rPr>
-              <a:t>Security &amp; Privacy</a:t>
-            </a:r>
-          </a:p>
-        </p:txBody>
-      </p:sp>
-      <p:sp>
-        <p:nvSpPr>
-          <p:cNvPr id="23" name="TextBox 22"/>
-          <p:cNvSpPr txBox="1"/>
-          <p:nvPr/>
-        </p:nvSpPr>
-        <p:spPr>
-          <a:xfrm>
-            <a:off x="502920" y="5285232"/>
-            <a:ext cx="2560320" cy="1097280"/>
-          </a:xfrm>
-          <a:prstGeom prst="rect">
-            <a:avLst/>
-          </a:prstGeom>
-          <a:noFill/>
-        </p:spPr>
-        <p:txBody>
-          <a:bodyPr wrap="square" anchor="t" lIns="73152" rIns="73152" tIns="36576" bIns="36576">
-            <a:spAutoFit/>
-          </a:bodyPr>
-          <a:lstStyle/>
-          <a:p>
-            <a:pPr algn="l">
-              <a:lnSpc>
-                <a:spcPct val="105000"/>
-              </a:lnSpc>
-              <a:spcAft>
-                <a:spcPts val="200"/>
-              </a:spcAft>
-            </a:pPr>
-            <a:r>
-              <a:rPr sz="950" b="0">
-                <a:solidFill>
-                  <a:srgbClr val="EEF2F8"/>
-                </a:solidFill>
-                <a:latin typeface="Calibri"/>
-              </a:rPr>
-              <a:t>• Local-first; no external AI service</a:t>
-            </a:r>
-          </a:p>
-          <a:p>
-            <a:pPr algn="l">
-              <a:lnSpc>
-                <a:spcPct val="105000"/>
-              </a:lnSpc>
-              <a:spcAft>
-                <a:spcPts val="200"/>
-              </a:spcAft>
-            </a:pPr>
-            <a:r>
-              <a:rPr sz="950" b="0">
-                <a:solidFill>
-                  <a:srgbClr val="EEF2F8"/>
-                </a:solidFill>
-                <a:latin typeface="Calibri"/>
-              </a:rPr>
-              <a:t>• Anonymized identifiers in demos</a:t>
-            </a:r>
-          </a:p>
-          <a:p>
-            <a:pPr algn="l">
-              <a:lnSpc>
-                <a:spcPct val="105000"/>
-              </a:lnSpc>
-              <a:spcAft>
-                <a:spcPts val="200"/>
-              </a:spcAft>
-            </a:pPr>
-            <a:r>
-              <a:rPr sz="950" b="0">
-                <a:solidFill>
-                  <a:srgbClr val="EEF2F8"/>
-                </a:solidFill>
-                <a:latin typeface="Calibri"/>
-              </a:rPr>
-              <a:t>• No secrets/captures committed</a:t>
-            </a:r>
-          </a:p>
-          <a:p>
-            <a:pPr algn="l">
-              <a:lnSpc>
-                <a:spcPct val="105000"/>
-              </a:lnSpc>
-              <a:spcAft>
-                <a:spcPts val="200"/>
-              </a:spcAft>
-            </a:pPr>
-            <a:r>
-              <a:rPr sz="950" b="0">
-                <a:solidFill>
-                  <a:srgbClr val="EEF2F8"/>
-                </a:solidFill>
-                <a:latin typeface="Calibri"/>
-              </a:rPr>
-              <a:t>• Provenance, versions, checksums</a:t>
-            </a:r>
-          </a:p>
-          <a:p>
-            <a:pPr algn="l">
-              <a:lnSpc>
-                <a:spcPct val="105000"/>
-              </a:lnSpc>
-              <a:spcAft>
-                <a:spcPts val="200"/>
-              </a:spcAft>
-            </a:pPr>
-            <a:r>
-              <a:rPr sz="950" b="0">
-                <a:solidFill>
-                  <a:srgbClr val="EEF2F8"/>
-                </a:solidFill>
-                <a:latin typeface="Calibri"/>
-              </a:rPr>
-              <a:t>• Human-in-the-loop; no auto-blocking</a:t>
-            </a:r>
-          </a:p>
-        </p:txBody>
-      </p:sp>
-      <p:sp>
-        <p:nvSpPr>
-          <p:cNvPr id="24" name="Rounded Rectangle 23"/>
-          <p:cNvSpPr/>
-          <p:nvPr/>
-        </p:nvSpPr>
-        <p:spPr>
-          <a:xfrm>
-            <a:off x="3291840" y="4846320"/>
-            <a:ext cx="2788920" cy="1600200"/>
-          </a:xfrm>
-          <a:prstGeom prst="roundRect">
-            <a:avLst>
-              <a:gd name="adj" fmla="val 6000"/>
-            </a:avLst>
-          </a:prstGeom>
-          <a:solidFill>
-            <a:srgbClr val="141E33"/>
-          </a:solidFill>
-          <a:ln>
-            <a:noFill/>
-          </a:ln>
-          <a:effectLst/>
-        </p:spPr>
-        <p:style>
-          <a:lnRef idx="1">
-            <a:schemeClr val="accent1"/>
-          </a:lnRef>
-          <a:fillRef idx="3">
-            <a:schemeClr val="accent1"/>
-          </a:fillRef>
-          <a:effectRef idx="2">
-            <a:schemeClr val="accent1"/>
-          </a:effectRef>
-          <a:fontRef idx="minor">
-            <a:schemeClr val="lt1"/>
-          </a:fontRef>
-        </p:style>
-        <p:txBody>
-          <a:bodyPr rtlCol="0" anchor="ctr"/>
-          <a:lstStyle/>
-          <a:p>
-            <a:pPr algn="ctr"/>
-          </a:p>
-        </p:txBody>
-      </p:sp>
-      <p:sp>
-        <p:nvSpPr>
-          <p:cNvPr id="25" name="TextBox 24"/>
-          <p:cNvSpPr txBox="1"/>
-          <p:nvPr/>
-        </p:nvSpPr>
-        <p:spPr>
-          <a:xfrm>
-            <a:off x="3383280" y="4919472"/>
-            <a:ext cx="2606040" cy="365760"/>
-          </a:xfrm>
-          <a:prstGeom prst="rect">
-            <a:avLst/>
-          </a:prstGeom>
-          <a:noFill/>
-        </p:spPr>
-        <p:txBody>
-          <a:bodyPr wrap="square" anchor="t" lIns="73152" rIns="73152" tIns="36576" bIns="36576">
-            <a:spAutoFit/>
-          </a:bodyPr>
-          <a:lstStyle/>
-          <a:p>
-            <a:pPr algn="l">
-              <a:lnSpc>
-                <a:spcPct val="105000"/>
-              </a:lnSpc>
-              <a:spcAft>
-                <a:spcPts val="200"/>
-              </a:spcAft>
-            </a:pPr>
-            <a:r>
-              <a:rPr sz="1300" b="1">
-                <a:solidFill>
-                  <a:srgbClr val="2ED3B7"/>
-                </a:solidFill>
-                <a:latin typeface="Calibri"/>
-              </a:rPr>
-              <a:t>Input Fallback Logic</a:t>
-            </a:r>
-          </a:p>
-        </p:txBody>
-      </p:sp>
-      <p:sp>
-        <p:nvSpPr>
-          <p:cNvPr id="26" name="TextBox 25"/>
-          <p:cNvSpPr txBox="1"/>
-          <p:nvPr/>
-        </p:nvSpPr>
-        <p:spPr>
-          <a:xfrm>
-            <a:off x="3383280" y="5285232"/>
-            <a:ext cx="2606040" cy="1097280"/>
-          </a:xfrm>
-          <a:prstGeom prst="rect">
-            <a:avLst/>
-          </a:prstGeom>
-          <a:noFill/>
-        </p:spPr>
-        <p:txBody>
-          <a:bodyPr wrap="square" anchor="t" lIns="73152" rIns="73152" tIns="36576" bIns="36576">
-            <a:spAutoFit/>
-          </a:bodyPr>
-          <a:lstStyle/>
-          <a:p>
-            <a:pPr algn="l">
-              <a:lnSpc>
-                <a:spcPct val="105000"/>
-              </a:lnSpc>
-              <a:spcAft>
-                <a:spcPts val="200"/>
-              </a:spcAft>
-            </a:pPr>
-            <a:r>
-              <a:rPr sz="950" b="0">
-                <a:solidFill>
-                  <a:srgbClr val="EEF2F8"/>
-                </a:solidFill>
-                <a:latin typeface="Calibri"/>
-              </a:rPr>
-              <a:t>• PCAP -&gt; flow + packet features</a:t>
-            </a:r>
-          </a:p>
-          <a:p>
-            <a:pPr algn="l">
-              <a:lnSpc>
-                <a:spcPct val="105000"/>
-              </a:lnSpc>
-              <a:spcAft>
-                <a:spcPts val="200"/>
-              </a:spcAft>
-            </a:pPr>
-            <a:r>
-              <a:rPr sz="950" b="0">
-                <a:solidFill>
-                  <a:srgbClr val="EEF2F8"/>
-                </a:solidFill>
-                <a:latin typeface="Calibri"/>
-              </a:rPr>
-              <a:t>• CSV only -&gt; flow features + packet-coverage warning</a:t>
-            </a:r>
-          </a:p>
-          <a:p>
-            <a:pPr algn="l">
-              <a:lnSpc>
-                <a:spcPct val="105000"/>
-              </a:lnSpc>
-              <a:spcAft>
-                <a:spcPts val="200"/>
-              </a:spcAft>
-            </a:pPr>
-            <a:r>
-              <a:rPr sz="950" b="0">
-                <a:solidFill>
-                  <a:srgbClr val="EEF2F8"/>
-                </a:solidFill>
-                <a:latin typeface="Calibri"/>
-              </a:rPr>
-              <a:t>• Data missing -&gt; validation error, no fabricated forecast</a:t>
-            </a:r>
-          </a:p>
-          <a:p>
-            <a:pPr algn="l">
-              <a:lnSpc>
-                <a:spcPct val="105000"/>
-              </a:lnSpc>
-              <a:spcAft>
-                <a:spcPts val="200"/>
-              </a:spcAft>
-            </a:pPr>
-            <a:r>
-              <a:rPr sz="950" b="0">
-                <a:solidFill>
-                  <a:srgbClr val="EEF2F8"/>
-                </a:solidFill>
-                <a:latin typeface="Calibri"/>
-              </a:rPr>
-              <a:t>• All paths run offline</a:t>
-            </a:r>
-          </a:p>
-        </p:txBody>
-      </p:sp>
-      <p:sp>
-        <p:nvSpPr>
-          <p:cNvPr id="27" name="TextBox 26"/>
-          <p:cNvSpPr txBox="1"/>
-          <p:nvPr/>
-        </p:nvSpPr>
-        <p:spPr>
-          <a:xfrm>
-            <a:off x="6309360" y="1005840"/>
-            <a:ext cx="5470855" cy="274320"/>
-          </a:xfrm>
-          <a:prstGeom prst="rect">
-            <a:avLst/>
-          </a:prstGeom>
-          <a:noFill/>
-        </p:spPr>
-        <p:txBody>
-          <a:bodyPr wrap="square" anchor="t" lIns="73152" rIns="73152" tIns="36576" bIns="36576">
-            <a:spAutoFit/>
-          </a:bodyPr>
-          <a:lstStyle/>
-          <a:p>
-            <a:pPr algn="l">
-              <a:lnSpc>
-                <a:spcPct val="105000"/>
-              </a:lnSpc>
-              <a:spcAft>
-                <a:spcPts val="200"/>
-              </a:spcAft>
-            </a:pPr>
-            <a:r>
-              <a:rPr sz="1100" b="1">
-                <a:solidFill>
-                  <a:srgbClr val="2ED3B7"/>
-                </a:solidFill>
-                <a:latin typeface="Calibri"/>
-              </a:rPr>
-              <a:t>TECHNICAL APPROACH FLOW</a:t>
-            </a:r>
-          </a:p>
-        </p:txBody>
-      </p:sp>
-      <p:sp>
-        <p:nvSpPr>
-          <p:cNvPr id="28" name="Rounded Rectangle 27"/>
-          <p:cNvSpPr/>
-          <p:nvPr/>
-        </p:nvSpPr>
-        <p:spPr>
-          <a:xfrm>
-            <a:off x="6309360" y="1325880"/>
-            <a:ext cx="1230553" cy="548640"/>
+            <a:off x="411480" y="4114800"/>
+            <a:ext cx="5669280" cy="548640"/>
           </a:xfrm>
           <a:prstGeom prst="roundRect">
             <a:avLst>
@@ -7651,30 +7216,848 @@
           </a:fontRef>
         </p:style>
         <p:txBody>
-          <a:bodyPr rtlCol="0" anchor="ctr" wrap="square"/>
+          <a:bodyPr rtlCol="0" anchor="ctr"/>
           <a:lstStyle/>
           <a:p>
             <a:pPr algn="ctr"/>
+          </a:p>
+        </p:txBody>
+      </p:sp>
+      <p:sp>
+        <p:nvSpPr>
+          <p:cNvPr id="22" name="TextBox 21"/>
+          <p:cNvSpPr txBox="1"/>
+          <p:nvPr/>
+        </p:nvSpPr>
+        <p:spPr>
+          <a:xfrm>
+            <a:off x="502920" y="4160520"/>
+            <a:ext cx="1005840" cy="457200"/>
+          </a:xfrm>
+          <a:prstGeom prst="rect">
+            <a:avLst/>
+          </a:prstGeom>
+          <a:noFill/>
+        </p:spPr>
+        <p:txBody>
+          <a:bodyPr wrap="square" anchor="ctr" lIns="73152" rIns="73152" tIns="36576" bIns="36576">
+            <a:spAutoFit/>
+          </a:bodyPr>
+          <a:lstStyle/>
+          <a:p>
+            <a:pPr algn="l">
+              <a:lnSpc>
+                <a:spcPct val="105000"/>
+              </a:lnSpc>
+              <a:spcAft>
+                <a:spcPts val="200"/>
+              </a:spcAft>
+            </a:pPr>
+            <a:r>
+              <a:rPr sz="1100" b="1">
+                <a:solidFill>
+                  <a:srgbClr val="2ED3B7"/>
+                </a:solidFill>
+                <a:latin typeface="Calibri"/>
+              </a:rPr>
+              <a:t>UI</a:t>
+            </a:r>
+          </a:p>
+        </p:txBody>
+      </p:sp>
+      <p:sp>
+        <p:nvSpPr>
+          <p:cNvPr id="23" name="TextBox 22"/>
+          <p:cNvSpPr txBox="1"/>
+          <p:nvPr/>
+        </p:nvSpPr>
+        <p:spPr>
+          <a:xfrm>
+            <a:off x="1508760" y="4133088"/>
+            <a:ext cx="4480560" cy="512064"/>
+          </a:xfrm>
+          <a:prstGeom prst="rect">
+            <a:avLst/>
+          </a:prstGeom>
+          <a:noFill/>
+        </p:spPr>
+        <p:txBody>
+          <a:bodyPr wrap="square" anchor="ctr" lIns="73152" rIns="73152" tIns="36576" bIns="36576">
+            <a:spAutoFit/>
+          </a:bodyPr>
+          <a:lstStyle/>
+          <a:p>
+            <a:pPr algn="l">
+              <a:lnSpc>
+                <a:spcPct val="105000"/>
+              </a:lnSpc>
+              <a:spcAft>
+                <a:spcPts val="200"/>
+              </a:spcAft>
+            </a:pPr>
+            <a:r>
+              <a:rPr sz="950" b="0">
+                <a:solidFill>
+                  <a:srgbClr val="EEF2F8"/>
+                </a:solidFill>
+                <a:latin typeface="Calibri"/>
+              </a:rPr>
+              <a:t>Offline analyst dashboard (Streamlit + Plotly)</a:t>
+            </a:r>
+          </a:p>
+        </p:txBody>
+      </p:sp>
+      <p:sp>
+        <p:nvSpPr>
+          <p:cNvPr id="24" name="Rounded Rectangle 23"/>
+          <p:cNvSpPr/>
+          <p:nvPr/>
+        </p:nvSpPr>
+        <p:spPr>
+          <a:xfrm>
+            <a:off x="411480" y="4846320"/>
+            <a:ext cx="1828800" cy="1600200"/>
+          </a:xfrm>
+          <a:prstGeom prst="roundRect">
+            <a:avLst>
+              <a:gd name="adj" fmla="val 6000"/>
+            </a:avLst>
+          </a:prstGeom>
+          <a:solidFill>
+            <a:srgbClr val="141E33"/>
+          </a:solidFill>
+          <a:ln>
+            <a:noFill/>
+          </a:ln>
+          <a:effectLst/>
+        </p:spPr>
+        <p:style>
+          <a:lnRef idx="1">
+            <a:schemeClr val="accent1"/>
+          </a:lnRef>
+          <a:fillRef idx="3">
+            <a:schemeClr val="accent1"/>
+          </a:fillRef>
+          <a:effectRef idx="2">
+            <a:schemeClr val="accent1"/>
+          </a:effectRef>
+          <a:fontRef idx="minor">
+            <a:schemeClr val="lt1"/>
+          </a:fontRef>
+        </p:style>
+        <p:txBody>
+          <a:bodyPr rtlCol="0" anchor="ctr"/>
+          <a:lstStyle/>
+          <a:p>
+            <a:pPr algn="ctr"/>
+          </a:p>
+        </p:txBody>
+      </p:sp>
+      <p:sp>
+        <p:nvSpPr>
+          <p:cNvPr id="25" name="TextBox 24"/>
+          <p:cNvSpPr txBox="1"/>
+          <p:nvPr/>
+        </p:nvSpPr>
+        <p:spPr>
+          <a:xfrm>
+            <a:off x="502920" y="4919472"/>
+            <a:ext cx="1645920" cy="365760"/>
+          </a:xfrm>
+          <a:prstGeom prst="rect">
+            <a:avLst/>
+          </a:prstGeom>
+          <a:noFill/>
+        </p:spPr>
+        <p:txBody>
+          <a:bodyPr wrap="square" anchor="t" lIns="73152" rIns="73152" tIns="36576" bIns="36576">
+            <a:spAutoFit/>
+          </a:bodyPr>
+          <a:lstStyle/>
+          <a:p>
+            <a:pPr algn="l">
+              <a:lnSpc>
+                <a:spcPct val="105000"/>
+              </a:lnSpc>
+              <a:spcAft>
+                <a:spcPts val="200"/>
+              </a:spcAft>
+            </a:pPr>
+            <a:r>
+              <a:rPr sz="1300" b="1">
+                <a:solidFill>
+                  <a:srgbClr val="2ED3B7"/>
+                </a:solidFill>
+                <a:latin typeface="Calibri"/>
+              </a:rPr>
+              <a:t>Security &amp; Privacy</a:t>
+            </a:r>
+          </a:p>
+        </p:txBody>
+      </p:sp>
+      <p:sp>
+        <p:nvSpPr>
+          <p:cNvPr id="26" name="TextBox 25"/>
+          <p:cNvSpPr txBox="1"/>
+          <p:nvPr/>
+        </p:nvSpPr>
+        <p:spPr>
+          <a:xfrm>
+            <a:off x="502920" y="5285232"/>
+            <a:ext cx="1645920" cy="1097280"/>
+          </a:xfrm>
+          <a:prstGeom prst="rect">
+            <a:avLst/>
+          </a:prstGeom>
+          <a:noFill/>
+        </p:spPr>
+        <p:txBody>
+          <a:bodyPr wrap="square" anchor="t" lIns="73152" rIns="73152" tIns="36576" bIns="36576">
+            <a:spAutoFit/>
+          </a:bodyPr>
+          <a:lstStyle/>
+          <a:p>
+            <a:pPr algn="l">
+              <a:lnSpc>
+                <a:spcPct val="105000"/>
+              </a:lnSpc>
+              <a:spcAft>
+                <a:spcPts val="200"/>
+              </a:spcAft>
+            </a:pPr>
+            <a:r>
+              <a:rPr sz="850" b="0">
+                <a:solidFill>
+                  <a:srgbClr val="EEF2F8"/>
+                </a:solidFill>
+                <a:latin typeface="Calibri"/>
+              </a:rPr>
+              <a:t>• Local-first; no external AI service</a:t>
+            </a:r>
+          </a:p>
+          <a:p>
+            <a:pPr algn="l">
+              <a:lnSpc>
+                <a:spcPct val="105000"/>
+              </a:lnSpc>
+              <a:spcAft>
+                <a:spcPts val="200"/>
+              </a:spcAft>
+            </a:pPr>
+            <a:r>
+              <a:rPr sz="850" b="0">
+                <a:solidFill>
+                  <a:srgbClr val="EEF2F8"/>
+                </a:solidFill>
+                <a:latin typeface="Calibri"/>
+              </a:rPr>
+              <a:t>• API keys hashed (SHA-256) + RBAC</a:t>
+            </a:r>
+          </a:p>
+          <a:p>
+            <a:pPr algn="l">
+              <a:lnSpc>
+                <a:spcPct val="105000"/>
+              </a:lnSpc>
+              <a:spcAft>
+                <a:spcPts val="200"/>
+              </a:spcAft>
+            </a:pPr>
+            <a:r>
+              <a:rPr sz="850" b="0">
+                <a:solidFill>
+                  <a:srgbClr val="EEF2F8"/>
+                </a:solidFill>
+                <a:latin typeface="Calibri"/>
+              </a:rPr>
+              <a:t>• Anonymized identifiers in demos</a:t>
+            </a:r>
+          </a:p>
+          <a:p>
+            <a:pPr algn="l">
+              <a:lnSpc>
+                <a:spcPct val="105000"/>
+              </a:lnSpc>
+              <a:spcAft>
+                <a:spcPts val="200"/>
+              </a:spcAft>
+            </a:pPr>
+            <a:r>
+              <a:rPr sz="850" b="0">
+                <a:solidFill>
+                  <a:srgbClr val="EEF2F8"/>
+                </a:solidFill>
+                <a:latin typeface="Calibri"/>
+              </a:rPr>
+              <a:t>• No secrets/captures committed</a:t>
+            </a:r>
+          </a:p>
+          <a:p>
+            <a:pPr algn="l">
+              <a:lnSpc>
+                <a:spcPct val="105000"/>
+              </a:lnSpc>
+              <a:spcAft>
+                <a:spcPts val="200"/>
+              </a:spcAft>
+            </a:pPr>
+            <a:r>
+              <a:rPr sz="850" b="0">
+                <a:solidFill>
+                  <a:srgbClr val="EEF2F8"/>
+                </a:solidFill>
+                <a:latin typeface="Calibri"/>
+              </a:rPr>
+              <a:t>• Missing input -&gt; error, never a fabricated forecast</a:t>
+            </a:r>
+          </a:p>
+        </p:txBody>
+      </p:sp>
+      <p:sp>
+        <p:nvSpPr>
+          <p:cNvPr id="27" name="Rounded Rectangle 26"/>
+          <p:cNvSpPr/>
+          <p:nvPr/>
+        </p:nvSpPr>
+        <p:spPr>
+          <a:xfrm>
+            <a:off x="2377440" y="4846320"/>
+            <a:ext cx="1874519" cy="1600200"/>
+          </a:xfrm>
+          <a:prstGeom prst="roundRect">
+            <a:avLst>
+              <a:gd name="adj" fmla="val 6000"/>
+            </a:avLst>
+          </a:prstGeom>
+          <a:solidFill>
+            <a:srgbClr val="141E33"/>
+          </a:solidFill>
+          <a:ln>
+            <a:noFill/>
+          </a:ln>
+          <a:effectLst/>
+        </p:spPr>
+        <p:style>
+          <a:lnRef idx="1">
+            <a:schemeClr val="accent1"/>
+          </a:lnRef>
+          <a:fillRef idx="3">
+            <a:schemeClr val="accent1"/>
+          </a:fillRef>
+          <a:effectRef idx="2">
+            <a:schemeClr val="accent1"/>
+          </a:effectRef>
+          <a:fontRef idx="minor">
+            <a:schemeClr val="lt1"/>
+          </a:fontRef>
+        </p:style>
+        <p:txBody>
+          <a:bodyPr rtlCol="0" anchor="ctr"/>
+          <a:lstStyle/>
+          <a:p>
+            <a:pPr algn="ctr"/>
+          </a:p>
+        </p:txBody>
+      </p:sp>
+      <p:sp>
+        <p:nvSpPr>
+          <p:cNvPr id="28" name="TextBox 27"/>
+          <p:cNvSpPr txBox="1"/>
+          <p:nvPr/>
+        </p:nvSpPr>
+        <p:spPr>
+          <a:xfrm>
+            <a:off x="2468880" y="4919472"/>
+            <a:ext cx="1691639" cy="365760"/>
+          </a:xfrm>
+          <a:prstGeom prst="rect">
+            <a:avLst/>
+          </a:prstGeom>
+          <a:noFill/>
+        </p:spPr>
+        <p:txBody>
+          <a:bodyPr wrap="square" anchor="t" lIns="73152" rIns="73152" tIns="36576" bIns="36576">
+            <a:spAutoFit/>
+          </a:bodyPr>
+          <a:lstStyle/>
+          <a:p>
+            <a:pPr algn="l">
+              <a:lnSpc>
+                <a:spcPct val="105000"/>
+              </a:lnSpc>
+              <a:spcAft>
+                <a:spcPts val="200"/>
+              </a:spcAft>
+            </a:pPr>
+            <a:r>
+              <a:rPr sz="1300" b="1">
+                <a:solidFill>
+                  <a:srgbClr val="2ED3B7"/>
+                </a:solidFill>
+                <a:latin typeface="Calibri"/>
+              </a:rPr>
+              <a:t>Authentication Flow</a:t>
+            </a:r>
+          </a:p>
+        </p:txBody>
+      </p:sp>
+      <p:sp>
+        <p:nvSpPr>
+          <p:cNvPr id="29" name="TextBox 28"/>
+          <p:cNvSpPr txBox="1"/>
+          <p:nvPr/>
+        </p:nvSpPr>
+        <p:spPr>
+          <a:xfrm>
+            <a:off x="2468880" y="5285232"/>
+            <a:ext cx="1691639" cy="1097280"/>
+          </a:xfrm>
+          <a:prstGeom prst="rect">
+            <a:avLst/>
+          </a:prstGeom>
+          <a:noFill/>
+        </p:spPr>
+        <p:txBody>
+          <a:bodyPr wrap="square" anchor="t" lIns="73152" rIns="73152" tIns="36576" bIns="36576">
+            <a:spAutoFit/>
+          </a:bodyPr>
+          <a:lstStyle/>
+          <a:p>
+            <a:pPr algn="l">
+              <a:lnSpc>
+                <a:spcPct val="105000"/>
+              </a:lnSpc>
+              <a:spcAft>
+                <a:spcPts val="200"/>
+              </a:spcAft>
+            </a:pPr>
+            <a:r>
+              <a:rPr sz="850" b="0">
+                <a:solidFill>
+                  <a:srgbClr val="EEF2F8"/>
+                </a:solidFill>
+                <a:latin typeface="Calibri"/>
+              </a:rPr>
+              <a:t>• POST /admin/keys -&gt; sent_… key shown once</a:t>
+            </a:r>
+          </a:p>
+          <a:p>
+            <a:pPr algn="l">
+              <a:lnSpc>
+                <a:spcPct val="105000"/>
+              </a:lnSpc>
+              <a:spcAft>
+                <a:spcPts val="200"/>
+              </a:spcAft>
+            </a:pPr>
+            <a:r>
+              <a:rPr sz="850" b="0">
+                <a:solidFill>
+                  <a:srgbClr val="EEF2F8"/>
+                </a:solidFill>
+                <a:latin typeface="Calibri"/>
+              </a:rPr>
+              <a:t>• Only SHA-256 hashes stored</a:t>
+            </a:r>
+          </a:p>
+          <a:p>
+            <a:pPr algn="l">
+              <a:lnSpc>
+                <a:spcPct val="105000"/>
+              </a:lnSpc>
+              <a:spcAft>
+                <a:spcPts val="200"/>
+              </a:spcAft>
+            </a:pPr>
+            <a:r>
+              <a:rPr sz="850" b="0">
+                <a:solidFill>
+                  <a:srgbClr val="EEF2F8"/>
+                </a:solidFill>
+                <a:latin typeface="Calibri"/>
+              </a:rPr>
+              <a:t>• X-API-Key header on every request</a:t>
+            </a:r>
+          </a:p>
+          <a:p>
+            <a:pPr algn="l">
+              <a:lnSpc>
+                <a:spcPct val="105000"/>
+              </a:lnSpc>
+              <a:spcAft>
+                <a:spcPts val="200"/>
+              </a:spcAft>
+            </a:pPr>
+            <a:r>
+              <a:rPr sz="850" b="0">
+                <a:solidFill>
+                  <a:srgbClr val="EEF2F8"/>
+                </a:solidFill>
+                <a:latin typeface="Calibri"/>
+              </a:rPr>
+              <a:t>• 401 unauthenticated · 403 wrong role</a:t>
+            </a:r>
+          </a:p>
+          <a:p>
+            <a:pPr algn="l">
+              <a:lnSpc>
+                <a:spcPct val="105000"/>
+              </a:lnSpc>
+              <a:spcAft>
+                <a:spcPts val="200"/>
+              </a:spcAft>
+            </a:pPr>
+            <a:r>
+              <a:rPr sz="850" b="0">
+                <a:solidFill>
+                  <a:srgbClr val="EEF2F8"/>
+                </a:solidFill>
+                <a:latin typeface="Calibri"/>
+              </a:rPr>
+              <a:t>• Revocation wins; every request audit-logged</a:t>
+            </a:r>
+          </a:p>
+        </p:txBody>
+      </p:sp>
+      <p:sp>
+        <p:nvSpPr>
+          <p:cNvPr id="30" name="TextBox 29"/>
+          <p:cNvSpPr txBox="1"/>
+          <p:nvPr/>
+        </p:nvSpPr>
+        <p:spPr>
+          <a:xfrm>
+            <a:off x="4389119" y="4846320"/>
+            <a:ext cx="1691640" cy="274320"/>
+          </a:xfrm>
+          <a:prstGeom prst="rect">
+            <a:avLst/>
+          </a:prstGeom>
+          <a:noFill/>
+        </p:spPr>
+        <p:txBody>
+          <a:bodyPr wrap="square" anchor="t" lIns="73152" rIns="73152" tIns="36576" bIns="36576">
+            <a:spAutoFit/>
+          </a:bodyPr>
+          <a:lstStyle/>
+          <a:p>
+            <a:pPr algn="l">
+              <a:lnSpc>
+                <a:spcPct val="105000"/>
+              </a:lnSpc>
+              <a:spcAft>
+                <a:spcPts val="200"/>
+              </a:spcAft>
+            </a:pPr>
             <a:r>
               <a:rPr sz="1000" b="1">
                 <a:solidFill>
-                  <a:srgbClr val="EEF2F8"/>
-                </a:solidFill>
-              </a:rPr>
-              <a:t>Ingest</a:t>
-            </a:r>
-          </a:p>
-        </p:txBody>
-      </p:sp>
-      <p:sp>
-        <p:nvSpPr>
-          <p:cNvPr id="29" name="Rounded Rectangle 28"/>
+                  <a:srgbClr val="2ED3B7"/>
+                </a:solidFill>
+                <a:latin typeface="Calibri"/>
+              </a:rPr>
+              <a:t>ROLE MATRIX (API)</a:t>
+            </a:r>
+          </a:p>
+        </p:txBody>
+      </p:sp>
+      <p:graphicFrame>
+        <p:nvGraphicFramePr>
+          <p:cNvPr id="31" name="Table 30"/>
+          <p:cNvGraphicFramePr>
+            <a:graphicFrameLocks noGrp="1"/>
+          </p:cNvGraphicFramePr>
+          <p:nvPr/>
+        </p:nvGraphicFramePr>
+        <p:xfrm>
+          <a:off x="4389119" y="5138928"/>
+          <a:ext cx="1691640" cy="1188720"/>
+        </p:xfrm>
+        <a:graphic>
+          <a:graphicData uri="http://schemas.openxmlformats.org/drawingml/2006/table">
+            <a:tbl>
+              <a:tblPr firstRow="1" bandRow="1">
+                <a:tableStyleId>{5C22544A-7EE6-4342-B048-85BDC9FD1C3A}</a:tableStyleId>
+              </a:tblPr>
+              <a:tblGrid>
+                <a:gridCol w="502920"/>
+                <a:gridCol w="1188720"/>
+              </a:tblGrid>
+              <a:tr h="237744">
+                <a:tc>
+                  <a:txBody>
+                    <a:bodyPr wrap="square"/>
+                    <a:lstStyle/>
+                    <a:p>
+                      <a:r>
+                        <a:rPr sz="850" b="1">
+                          <a:solidFill>
+                            <a:srgbClr val="2ED3B7"/>
+                          </a:solidFill>
+                        </a:rPr>
+                        <a:t>Role</a:t>
+                      </a:r>
+                    </a:p>
+                  </a:txBody>
+                  <a:tcPr marL="54864" marR="54864" marT="27432" marB="27432">
+                    <a:solidFill>
+                      <a:srgbClr val="1B2844"/>
+                    </a:solidFill>
+                  </a:tcPr>
+                </a:tc>
+                <a:tc>
+                  <a:txBody>
+                    <a:bodyPr wrap="square"/>
+                    <a:lstStyle/>
+                    <a:p>
+                      <a:r>
+                        <a:rPr sz="850" b="1">
+                          <a:solidFill>
+                            <a:srgbClr val="2ED3B7"/>
+                          </a:solidFill>
+                        </a:rPr>
+                        <a:t>API access</a:t>
+                      </a:r>
+                    </a:p>
+                  </a:txBody>
+                  <a:tcPr marL="54864" marR="54864" marT="27432" marB="27432">
+                    <a:solidFill>
+                      <a:srgbClr val="1B2844"/>
+                    </a:solidFill>
+                  </a:tcPr>
+                </a:tc>
+              </a:tr>
+              <a:tr h="237744">
+                <a:tc>
+                  <a:txBody>
+                    <a:bodyPr wrap="square"/>
+                    <a:lstStyle/>
+                    <a:p>
+                      <a:r>
+                        <a:rPr sz="850" b="0">
+                          <a:solidFill>
+                            <a:srgbClr val="EEF2F8"/>
+                          </a:solidFill>
+                        </a:rPr>
+                        <a:t>viewer</a:t>
+                      </a:r>
+                    </a:p>
+                  </a:txBody>
+                  <a:tcPr marL="54864" marR="54864" marT="27432" marB="27432">
+                    <a:solidFill>
+                      <a:srgbClr val="141E33"/>
+                    </a:solidFill>
+                  </a:tcPr>
+                </a:tc>
+                <a:tc>
+                  <a:txBody>
+                    <a:bodyPr wrap="square"/>
+                    <a:lstStyle/>
+                    <a:p>
+                      <a:r>
+                        <a:rPr sz="850" b="0">
+                          <a:solidFill>
+                            <a:srgbClr val="EEF2F8"/>
+                          </a:solidFill>
+                        </a:rPr>
+                        <a:t>read-only</a:t>
+                      </a:r>
+                    </a:p>
+                  </a:txBody>
+                  <a:tcPr marL="54864" marR="54864" marT="27432" marB="27432">
+                    <a:solidFill>
+                      <a:srgbClr val="141E33"/>
+                    </a:solidFill>
+                  </a:tcPr>
+                </a:tc>
+              </a:tr>
+              <a:tr h="237744">
+                <a:tc>
+                  <a:txBody>
+                    <a:bodyPr wrap="square"/>
+                    <a:lstStyle/>
+                    <a:p>
+                      <a:r>
+                        <a:rPr sz="850" b="0">
+                          <a:solidFill>
+                            <a:srgbClr val="EEF2F8"/>
+                          </a:solidFill>
+                        </a:rPr>
+                        <a:t>analyst</a:t>
+                      </a:r>
+                    </a:p>
+                  </a:txBody>
+                  <a:tcPr marL="54864" marR="54864" marT="27432" marB="27432">
+                    <a:solidFill>
+                      <a:srgbClr val="0B1220"/>
+                    </a:solidFill>
+                  </a:tcPr>
+                </a:tc>
+                <a:tc>
+                  <a:txBody>
+                    <a:bodyPr wrap="square"/>
+                    <a:lstStyle/>
+                    <a:p>
+                      <a:r>
+                        <a:rPr sz="850" b="0">
+                          <a:solidFill>
+                            <a:srgbClr val="EEF2F8"/>
+                          </a:solidFill>
+                        </a:rPr>
+                        <a:t>forecast · detect</a:t>
+                      </a:r>
+                    </a:p>
+                  </a:txBody>
+                  <a:tcPr marL="54864" marR="54864" marT="27432" marB="27432">
+                    <a:solidFill>
+                      <a:srgbClr val="0B1220"/>
+                    </a:solidFill>
+                  </a:tcPr>
+                </a:tc>
+              </a:tr>
+              <a:tr h="237744">
+                <a:tc>
+                  <a:txBody>
+                    <a:bodyPr wrap="square"/>
+                    <a:lstStyle/>
+                    <a:p>
+                      <a:r>
+                        <a:rPr sz="850" b="0">
+                          <a:solidFill>
+                            <a:srgbClr val="EEF2F8"/>
+                          </a:solidFill>
+                        </a:rPr>
+                        <a:t>engineer</a:t>
+                      </a:r>
+                    </a:p>
+                  </a:txBody>
+                  <a:tcPr marL="54864" marR="54864" marT="27432" marB="27432">
+                    <a:solidFill>
+                      <a:srgbClr val="141E33"/>
+                    </a:solidFill>
+                  </a:tcPr>
+                </a:tc>
+                <a:tc>
+                  <a:txBody>
+                    <a:bodyPr wrap="square"/>
+                    <a:lstStyle/>
+                    <a:p>
+                      <a:r>
+                        <a:rPr sz="850" b="0">
+                          <a:solidFill>
+                            <a:srgbClr val="EEF2F8"/>
+                          </a:solidFill>
+                        </a:rPr>
+                        <a:t>+ list keys</a:t>
+                      </a:r>
+                    </a:p>
+                  </a:txBody>
+                  <a:tcPr marL="54864" marR="54864" marT="27432" marB="27432">
+                    <a:solidFill>
+                      <a:srgbClr val="141E33"/>
+                    </a:solidFill>
+                  </a:tcPr>
+                </a:tc>
+              </a:tr>
+              <a:tr h="237744">
+                <a:tc>
+                  <a:txBody>
+                    <a:bodyPr wrap="square"/>
+                    <a:lstStyle/>
+                    <a:p>
+                      <a:r>
+                        <a:rPr sz="850" b="0">
+                          <a:solidFill>
+                            <a:srgbClr val="EEF2F8"/>
+                          </a:solidFill>
+                        </a:rPr>
+                        <a:t>admin</a:t>
+                      </a:r>
+                    </a:p>
+                  </a:txBody>
+                  <a:tcPr marL="54864" marR="54864" marT="27432" marB="27432">
+                    <a:solidFill>
+                      <a:srgbClr val="0B1220"/>
+                    </a:solidFill>
+                  </a:tcPr>
+                </a:tc>
+                <a:tc>
+                  <a:txBody>
+                    <a:bodyPr wrap="square"/>
+                    <a:lstStyle/>
+                    <a:p>
+                      <a:r>
+                        <a:rPr sz="850" b="0">
+                          <a:solidFill>
+                            <a:srgbClr val="EEF2F8"/>
+                          </a:solidFill>
+                        </a:rPr>
+                        <a:t>full control</a:t>
+                      </a:r>
+                    </a:p>
+                  </a:txBody>
+                  <a:tcPr marL="54864" marR="54864" marT="27432" marB="27432">
+                    <a:solidFill>
+                      <a:srgbClr val="0B1220"/>
+                    </a:solidFill>
+                  </a:tcPr>
+                </a:tc>
+              </a:tr>
+            </a:tbl>
+          </a:graphicData>
+        </a:graphic>
+      </p:graphicFrame>
+      <p:sp>
+        <p:nvSpPr>
+          <p:cNvPr id="32" name="TextBox 31"/>
+          <p:cNvSpPr txBox="1"/>
+          <p:nvPr/>
+        </p:nvSpPr>
+        <p:spPr>
+          <a:xfrm>
+            <a:off x="6309360" y="1005840"/>
+            <a:ext cx="5470855" cy="274320"/>
+          </a:xfrm>
+          <a:prstGeom prst="rect">
+            <a:avLst/>
+          </a:prstGeom>
+          <a:noFill/>
+        </p:spPr>
+        <p:txBody>
+          <a:bodyPr wrap="square" anchor="t" lIns="73152" rIns="73152" tIns="36576" bIns="36576">
+            <a:spAutoFit/>
+          </a:bodyPr>
+          <a:lstStyle/>
+          <a:p>
+            <a:pPr algn="l">
+              <a:lnSpc>
+                <a:spcPct val="105000"/>
+              </a:lnSpc>
+              <a:spcAft>
+                <a:spcPts val="200"/>
+              </a:spcAft>
+            </a:pPr>
+            <a:r>
+              <a:rPr sz="1100" b="1">
+                <a:solidFill>
+                  <a:srgbClr val="2ED3B7"/>
+                </a:solidFill>
+                <a:latin typeface="Calibri"/>
+              </a:rPr>
+              <a:t>TECHNICAL APPROACH FLOW</a:t>
+            </a:r>
+          </a:p>
+        </p:txBody>
+      </p:sp>
+      <p:sp>
+        <p:nvSpPr>
+          <p:cNvPr id="33" name="Rounded Rectangle 32"/>
           <p:cNvSpPr/>
           <p:nvPr/>
         </p:nvSpPr>
         <p:spPr>
           <a:xfrm>
-            <a:off x="7722793" y="1325880"/>
+            <a:off x="6309360" y="1325880"/>
             <a:ext cx="1230553" cy="548640"/>
           </a:xfrm>
           <a:prstGeom prst="roundRect">
@@ -7717,20 +8100,20 @@
                   <a:srgbClr val="EEF2F8"/>
                 </a:solidFill>
               </a:rPr>
-              <a:t>Normalize</a:t>
-            </a:r>
-          </a:p>
-        </p:txBody>
-      </p:sp>
-      <p:sp>
-        <p:nvSpPr>
-          <p:cNvPr id="30" name="Rounded Rectangle 29"/>
+              <a:t>Ingest</a:t>
+            </a:r>
+          </a:p>
+        </p:txBody>
+      </p:sp>
+      <p:sp>
+        <p:nvSpPr>
+          <p:cNvPr id="34" name="Rounded Rectangle 33"/>
           <p:cNvSpPr/>
           <p:nvPr/>
         </p:nvSpPr>
         <p:spPr>
           <a:xfrm>
-            <a:off x="9136227" y="1325880"/>
+            <a:off x="7722793" y="1325880"/>
             <a:ext cx="1230553" cy="548640"/>
           </a:xfrm>
           <a:prstGeom prst="roundRect">
@@ -7773,20 +8156,20 @@
                   <a:srgbClr val="EEF2F8"/>
                 </a:solidFill>
               </a:rPr>
-              <a:t>Window</a:t>
-            </a:r>
-          </a:p>
-        </p:txBody>
-      </p:sp>
-      <p:sp>
-        <p:nvSpPr>
-          <p:cNvPr id="31" name="Rounded Rectangle 30"/>
+              <a:t>Normalize</a:t>
+            </a:r>
+          </a:p>
+        </p:txBody>
+      </p:sp>
+      <p:sp>
+        <p:nvSpPr>
+          <p:cNvPr id="35" name="Rounded Rectangle 34"/>
           <p:cNvSpPr/>
           <p:nvPr/>
         </p:nvSpPr>
         <p:spPr>
           <a:xfrm>
-            <a:off x="10549661" y="1325880"/>
+            <a:off x="9136227" y="1325880"/>
             <a:ext cx="1230553" cy="548640"/>
           </a:xfrm>
           <a:prstGeom prst="roundRect">
@@ -7829,125 +8212,20 @@
                   <a:srgbClr val="EEF2F8"/>
                 </a:solidFill>
               </a:rPr>
-              <a:t>Prepare</a:t>
-            </a:r>
-          </a:p>
-        </p:txBody>
-      </p:sp>
-      <p:cxnSp>
-        <p:nvCxnSpPr>
-          <p:cNvPr id="32" name="Connector 31"/>
-          <p:cNvCxnSpPr/>
-          <p:nvPr/>
-        </p:nvCxnSpPr>
-        <p:spPr>
-          <a:xfrm>
-            <a:off x="7539913" y="1600200"/>
-            <a:ext cx="182880" cy="0"/>
-          </a:xfrm>
-          <a:prstGeom prst="line">
-            <a:avLst/>
-          </a:prstGeom>
-          <a:ln w="25400">
-            <a:solidFill>
-              <a:srgbClr val="2ED3B7"/>
-            </a:solidFill>
-          </a:ln>
-        </p:spPr>
-        <p:style>
-          <a:lnRef idx="2">
-            <a:schemeClr val="accent1"/>
-          </a:lnRef>
-          <a:fillRef idx="0">
-            <a:schemeClr val="accent1"/>
-          </a:fillRef>
-          <a:effectRef idx="1">
-            <a:schemeClr val="accent1"/>
-          </a:effectRef>
-          <a:fontRef idx="minor">
-            <a:schemeClr val="tx1"/>
-          </a:fontRef>
-        </p:style>
-      </p:cxnSp>
-      <p:cxnSp>
-        <p:nvCxnSpPr>
-          <p:cNvPr id="33" name="Connector 32"/>
-          <p:cNvCxnSpPr/>
-          <p:nvPr/>
-        </p:nvCxnSpPr>
-        <p:spPr>
-          <a:xfrm>
-            <a:off x="8953346" y="1600200"/>
-            <a:ext cx="182881" cy="0"/>
-          </a:xfrm>
-          <a:prstGeom prst="line">
-            <a:avLst/>
-          </a:prstGeom>
-          <a:ln w="25400">
-            <a:solidFill>
-              <a:srgbClr val="2ED3B7"/>
-            </a:solidFill>
-          </a:ln>
-        </p:spPr>
-        <p:style>
-          <a:lnRef idx="2">
-            <a:schemeClr val="accent1"/>
-          </a:lnRef>
-          <a:fillRef idx="0">
-            <a:schemeClr val="accent1"/>
-          </a:fillRef>
-          <a:effectRef idx="1">
-            <a:schemeClr val="accent1"/>
-          </a:effectRef>
-          <a:fontRef idx="minor">
-            <a:schemeClr val="tx1"/>
-          </a:fontRef>
-        </p:style>
-      </p:cxnSp>
-      <p:cxnSp>
-        <p:nvCxnSpPr>
-          <p:cNvPr id="34" name="Connector 33"/>
-          <p:cNvCxnSpPr/>
-          <p:nvPr/>
-        </p:nvCxnSpPr>
-        <p:spPr>
-          <a:xfrm>
-            <a:off x="10366780" y="1600200"/>
-            <a:ext cx="182881" cy="0"/>
-          </a:xfrm>
-          <a:prstGeom prst="line">
-            <a:avLst/>
-          </a:prstGeom>
-          <a:ln w="25400">
-            <a:solidFill>
-              <a:srgbClr val="2ED3B7"/>
-            </a:solidFill>
-          </a:ln>
-        </p:spPr>
-        <p:style>
-          <a:lnRef idx="2">
-            <a:schemeClr val="accent1"/>
-          </a:lnRef>
-          <a:fillRef idx="0">
-            <a:schemeClr val="accent1"/>
-          </a:fillRef>
-          <a:effectRef idx="1">
-            <a:schemeClr val="accent1"/>
-          </a:effectRef>
-          <a:fontRef idx="minor">
-            <a:schemeClr val="tx1"/>
-          </a:fontRef>
-        </p:style>
-      </p:cxnSp>
-      <p:sp>
-        <p:nvSpPr>
-          <p:cNvPr id="35" name="Rounded Rectangle 34"/>
+              <a:t>Window</a:t>
+            </a:r>
+          </a:p>
+        </p:txBody>
+      </p:sp>
+      <p:sp>
+        <p:nvSpPr>
+          <p:cNvPr id="36" name="Rounded Rectangle 35"/>
           <p:cNvSpPr/>
           <p:nvPr/>
         </p:nvSpPr>
         <p:spPr>
           <a:xfrm>
-            <a:off x="6309360" y="2011680"/>
+            <a:off x="10549661" y="1325880"/>
             <a:ext cx="1230553" cy="548640"/>
           </a:xfrm>
           <a:prstGeom prst="roundRect">
@@ -7990,20 +8268,125 @@
                   <a:srgbClr val="EEF2F8"/>
                 </a:solidFill>
               </a:rPr>
-              <a:t>Learn</a:t>
-            </a:r>
-          </a:p>
-        </p:txBody>
-      </p:sp>
-      <p:sp>
-        <p:nvSpPr>
-          <p:cNvPr id="36" name="Rounded Rectangle 35"/>
+              <a:t>Prepare</a:t>
+            </a:r>
+          </a:p>
+        </p:txBody>
+      </p:sp>
+      <p:cxnSp>
+        <p:nvCxnSpPr>
+          <p:cNvPr id="37" name="Connector 36"/>
+          <p:cNvCxnSpPr/>
+          <p:nvPr/>
+        </p:nvCxnSpPr>
+        <p:spPr>
+          <a:xfrm>
+            <a:off x="7539913" y="1600200"/>
+            <a:ext cx="182880" cy="0"/>
+          </a:xfrm>
+          <a:prstGeom prst="line">
+            <a:avLst/>
+          </a:prstGeom>
+          <a:ln w="25400">
+            <a:solidFill>
+              <a:srgbClr val="2ED3B7"/>
+            </a:solidFill>
+          </a:ln>
+        </p:spPr>
+        <p:style>
+          <a:lnRef idx="2">
+            <a:schemeClr val="accent1"/>
+          </a:lnRef>
+          <a:fillRef idx="0">
+            <a:schemeClr val="accent1"/>
+          </a:fillRef>
+          <a:effectRef idx="1">
+            <a:schemeClr val="accent1"/>
+          </a:effectRef>
+          <a:fontRef idx="minor">
+            <a:schemeClr val="tx1"/>
+          </a:fontRef>
+        </p:style>
+      </p:cxnSp>
+      <p:cxnSp>
+        <p:nvCxnSpPr>
+          <p:cNvPr id="38" name="Connector 37"/>
+          <p:cNvCxnSpPr/>
+          <p:nvPr/>
+        </p:nvCxnSpPr>
+        <p:spPr>
+          <a:xfrm>
+            <a:off x="8953346" y="1600200"/>
+            <a:ext cx="182881" cy="0"/>
+          </a:xfrm>
+          <a:prstGeom prst="line">
+            <a:avLst/>
+          </a:prstGeom>
+          <a:ln w="25400">
+            <a:solidFill>
+              <a:srgbClr val="2ED3B7"/>
+            </a:solidFill>
+          </a:ln>
+        </p:spPr>
+        <p:style>
+          <a:lnRef idx="2">
+            <a:schemeClr val="accent1"/>
+          </a:lnRef>
+          <a:fillRef idx="0">
+            <a:schemeClr val="accent1"/>
+          </a:fillRef>
+          <a:effectRef idx="1">
+            <a:schemeClr val="accent1"/>
+          </a:effectRef>
+          <a:fontRef idx="minor">
+            <a:schemeClr val="tx1"/>
+          </a:fontRef>
+        </p:style>
+      </p:cxnSp>
+      <p:cxnSp>
+        <p:nvCxnSpPr>
+          <p:cNvPr id="39" name="Connector 38"/>
+          <p:cNvCxnSpPr/>
+          <p:nvPr/>
+        </p:nvCxnSpPr>
+        <p:spPr>
+          <a:xfrm>
+            <a:off x="10366780" y="1600200"/>
+            <a:ext cx="182881" cy="0"/>
+          </a:xfrm>
+          <a:prstGeom prst="line">
+            <a:avLst/>
+          </a:prstGeom>
+          <a:ln w="25400">
+            <a:solidFill>
+              <a:srgbClr val="2ED3B7"/>
+            </a:solidFill>
+          </a:ln>
+        </p:spPr>
+        <p:style>
+          <a:lnRef idx="2">
+            <a:schemeClr val="accent1"/>
+          </a:lnRef>
+          <a:fillRef idx="0">
+            <a:schemeClr val="accent1"/>
+          </a:fillRef>
+          <a:effectRef idx="1">
+            <a:schemeClr val="accent1"/>
+          </a:effectRef>
+          <a:fontRef idx="minor">
+            <a:schemeClr val="tx1"/>
+          </a:fontRef>
+        </p:style>
+      </p:cxnSp>
+      <p:sp>
+        <p:nvSpPr>
+          <p:cNvPr id="40" name="Rounded Rectangle 39"/>
           <p:cNvSpPr/>
           <p:nvPr/>
         </p:nvSpPr>
         <p:spPr>
           <a:xfrm>
-            <a:off x="7722793" y="2011680"/>
+            <a:off x="6309360" y="2011680"/>
             <a:ext cx="1230553" cy="548640"/>
           </a:xfrm>
           <a:prstGeom prst="roundRect">
@@ -8046,20 +8429,20 @@
                   <a:srgbClr val="EEF2F8"/>
                 </a:solidFill>
               </a:rPr>
-              <a:t>Simulate</a:t>
-            </a:r>
-          </a:p>
-        </p:txBody>
-      </p:sp>
-      <p:sp>
-        <p:nvSpPr>
-          <p:cNvPr id="37" name="Rounded Rectangle 36"/>
+              <a:t>Learn</a:t>
+            </a:r>
+          </a:p>
+        </p:txBody>
+      </p:sp>
+      <p:sp>
+        <p:nvSpPr>
+          <p:cNvPr id="41" name="Rounded Rectangle 40"/>
           <p:cNvSpPr/>
           <p:nvPr/>
         </p:nvSpPr>
         <p:spPr>
           <a:xfrm>
-            <a:off x="9136227" y="2011680"/>
+            <a:off x="7722793" y="2011680"/>
             <a:ext cx="1230553" cy="548640"/>
           </a:xfrm>
           <a:prstGeom prst="roundRect">
@@ -8102,20 +8485,20 @@
                   <a:srgbClr val="EEF2F8"/>
                 </a:solidFill>
               </a:rPr>
-              <a:t>Explain</a:t>
-            </a:r>
-          </a:p>
-        </p:txBody>
-      </p:sp>
-      <p:sp>
-        <p:nvSpPr>
-          <p:cNvPr id="38" name="Rounded Rectangle 37"/>
+              <a:t>Simulate</a:t>
+            </a:r>
+          </a:p>
+        </p:txBody>
+      </p:sp>
+      <p:sp>
+        <p:nvSpPr>
+          <p:cNvPr id="42" name="Rounded Rectangle 41"/>
           <p:cNvSpPr/>
           <p:nvPr/>
         </p:nvSpPr>
         <p:spPr>
           <a:xfrm>
-            <a:off x="10549661" y="2011680"/>
+            <a:off x="9136227" y="2011680"/>
             <a:ext cx="1230553" cy="548640"/>
           </a:xfrm>
           <a:prstGeom prst="roundRect">
@@ -8158,6 +8541,62 @@
                   <a:srgbClr val="EEF2F8"/>
                 </a:solidFill>
               </a:rPr>
+              <a:t>Explain</a:t>
+            </a:r>
+          </a:p>
+        </p:txBody>
+      </p:sp>
+      <p:sp>
+        <p:nvSpPr>
+          <p:cNvPr id="43" name="Rounded Rectangle 42"/>
+          <p:cNvSpPr/>
+          <p:nvPr/>
+        </p:nvSpPr>
+        <p:spPr>
+          <a:xfrm>
+            <a:off x="10549661" y="2011680"/>
+            <a:ext cx="1230553" cy="548640"/>
+          </a:xfrm>
+          <a:prstGeom prst="roundRect">
+            <a:avLst>
+              <a:gd name="adj" fmla="val 6000"/>
+            </a:avLst>
+          </a:prstGeom>
+          <a:solidFill>
+            <a:srgbClr val="1B2844"/>
+          </a:solidFill>
+          <a:ln w="12700">
+            <a:solidFill>
+              <a:srgbClr val="2ED3B7"/>
+            </a:solidFill>
+          </a:ln>
+          <a:effectLst/>
+        </p:spPr>
+        <p:style>
+          <a:lnRef idx="1">
+            <a:schemeClr val="accent1"/>
+          </a:lnRef>
+          <a:fillRef idx="3">
+            <a:schemeClr val="accent1"/>
+          </a:fillRef>
+          <a:effectRef idx="2">
+            <a:schemeClr val="accent1"/>
+          </a:effectRef>
+          <a:fontRef idx="minor">
+            <a:schemeClr val="lt1"/>
+          </a:fontRef>
+        </p:style>
+        <p:txBody>
+          <a:bodyPr rtlCol="0" anchor="ctr" wrap="square"/>
+          <a:lstStyle/>
+          <a:p>
+            <a:pPr algn="ctr"/>
+            <a:r>
+              <a:rPr sz="1000" b="1">
+                <a:solidFill>
+                  <a:srgbClr val="EEF2F8"/>
+                </a:solidFill>
+              </a:rPr>
               <a:t>Display</a:t>
             </a:r>
           </a:p>
@@ -8165,7 +8604,7 @@
       </p:sp>
       <p:cxnSp>
         <p:nvCxnSpPr>
-          <p:cNvPr id="39" name="Connector 38"/>
+          <p:cNvPr id="44" name="Connector 43"/>
           <p:cNvCxnSpPr/>
           <p:nvPr/>
         </p:nvCxnSpPr>
@@ -8200,7 +8639,7 @@
       </p:cxnSp>
       <p:cxnSp>
         <p:nvCxnSpPr>
-          <p:cNvPr id="40" name="Connector 39"/>
+          <p:cNvPr id="45" name="Connector 44"/>
           <p:cNvCxnSpPr/>
           <p:nvPr/>
         </p:nvCxnSpPr>
@@ -8235,7 +8674,7 @@
       </p:cxnSp>
       <p:cxnSp>
         <p:nvCxnSpPr>
-          <p:cNvPr id="41" name="Connector 40"/>
+          <p:cNvPr id="46" name="Connector 45"/>
           <p:cNvCxnSpPr/>
           <p:nvPr/>
         </p:nvCxnSpPr>
@@ -8270,7 +8709,7 @@
       </p:cxnSp>
       <p:sp>
         <p:nvSpPr>
-          <p:cNvPr id="42" name="TextBox 41"/>
+          <p:cNvPr id="47" name="TextBox 46"/>
           <p:cNvSpPr txBox="1"/>
           <p:nvPr/>
         </p:nvSpPr>
@@ -8312,7 +8751,7 @@
       </p:sp>
       <p:sp>
         <p:nvSpPr>
-          <p:cNvPr id="43" name="TextBox 42"/>
+          <p:cNvPr id="48" name="TextBox 47"/>
           <p:cNvSpPr txBox="1"/>
           <p:nvPr/>
         </p:nvSpPr>
@@ -8354,7 +8793,7 @@
       </p:sp>
       <p:graphicFrame>
         <p:nvGraphicFramePr>
-          <p:cNvPr id="44" name="Table 43"/>
+          <p:cNvPr id="49" name="Table 48"/>
           <p:cNvGraphicFramePr>
             <a:graphicFrameLocks noGrp="1"/>
           </p:cNvGraphicFramePr>
@@ -8836,7 +9275,7 @@
       </p:graphicFrame>
       <p:sp>
         <p:nvSpPr>
-          <p:cNvPr id="45" name="TextBox 44"/>
+          <p:cNvPr id="50" name="TextBox 49"/>
           <p:cNvSpPr txBox="1"/>
           <p:nvPr/>
         </p:nvSpPr>
@@ -8871,7 +9310,7 @@
                 </a:solidFill>
                 <a:latin typeface="Calibri"/>
               </a:rPr>
-              <a:t>No Kafka/cloud gateway/microservices are claimed: the prototype runs on local files and model artifacts. Docker only if packaged before submission.</a:t>
+              <a:t>Implemented: FastAPI REST + hashed API keys with a 4-role matrix + audit log. No Kafka/cloud gateway/microservices claimed; prototype runs on local files and artifacts.</a:t>
             </a:r>
           </a:p>
         </p:txBody>

</xml_diff>